<commit_message>
feat: adapt generator to updated 8D template
</commit_message>
<xml_diff>
--- a/8D模板.pptx
+++ b/8D模板.pptx
@@ -9,7 +9,7 @@
     <p:notesMasterId r:id="rId5"/>
   </p:notesMasterIdLst>
   <p:handoutMasterIdLst>
-    <p:handoutMasterId r:id="rId20"/>
+    <p:handoutMasterId r:id="rId19"/>
   </p:handoutMasterIdLst>
   <p:sldIdLst>
     <p:sldId id="353" r:id="rId4"/>
@@ -19,19 +19,18 @@
     <p:sldId id="531" r:id="rId9"/>
     <p:sldId id="412" r:id="rId10"/>
     <p:sldId id="613" r:id="rId11"/>
-    <p:sldId id="626" r:id="rId12"/>
-    <p:sldId id="619" r:id="rId13"/>
-    <p:sldId id="620" r:id="rId14"/>
-    <p:sldId id="577" r:id="rId15"/>
-    <p:sldId id="579" r:id="rId16"/>
-    <p:sldId id="580" r:id="rId17"/>
-    <p:sldId id="582" r:id="rId18"/>
-    <p:sldId id="411" r:id="rId19"/>
+    <p:sldId id="619" r:id="rId12"/>
+    <p:sldId id="620" r:id="rId13"/>
+    <p:sldId id="577" r:id="rId14"/>
+    <p:sldId id="579" r:id="rId15"/>
+    <p:sldId id="580" r:id="rId16"/>
+    <p:sldId id="582" r:id="rId17"/>
+    <p:sldId id="411" r:id="rId18"/>
   </p:sldIdLst>
   <p:sldSz cx="9144000" cy="5143500" type="screen16x9"/>
   <p:notesSz cx="6797675" cy="9926320"/>
   <p:custDataLst>
-    <p:tags r:id="rId25"/>
+    <p:tags r:id="rId24"/>
   </p:custDataLst>
   <p:defaultTextStyle>
     <a:defPPr>
@@ -979,7 +978,7 @@
       </p:grpSpPr>
       <p:sp>
         <p:nvSpPr>
-          <p:cNvPr id="19457" name="幻灯片图像占位符 1"/>
+          <p:cNvPr id="25601" name="幻灯片图像占位符 1"/>
           <p:cNvSpPr>
             <a:spLocks noGrp="1" noRot="1" noChangeAspect="1"/>
           </p:cNvSpPr>
@@ -991,7 +990,7 @@
       </p:sp>
       <p:sp>
         <p:nvSpPr>
-          <p:cNvPr id="19458" name="备注占位符 2"/>
+          <p:cNvPr id="25602" name="备注占位符 2"/>
           <p:cNvSpPr>
             <a:spLocks noGrp="1"/>
           </p:cNvSpPr>
@@ -1004,57 +1003,6 @@
           <a:bodyPr wrap="square" lIns="91440" tIns="45720" rIns="91440" bIns="45720" anchor="t"/>
           <a:lstStyle/>
           <a:p>
-            <a:pPr marL="0" marR="0" lvl="0" indent="0" algn="l" defTabSz="914400" rtl="0" eaLnBrk="1" fontAlgn="base" latinLnBrk="0" hangingPunct="1">
-              <a:lnSpc>
-                <a:spcPct val="100000"/>
-              </a:lnSpc>
-              <a:spcBef>
-                <a:spcPct val="0"/>
-              </a:spcBef>
-              <a:spcAft>
-                <a:spcPct val="0"/>
-              </a:spcAft>
-              <a:buClrTx/>
-              <a:buSzTx/>
-              <a:buFontTx/>
-              <a:buNone/>
-              <a:defRPr/>
-            </a:pPr>
-            <a:r>
-              <a:rPr lang="en-US" altLang="zh-CN" dirty="0" smtClean="0"/>
-              <a:t>1</a:t>
-            </a:r>
-            <a:r>
-              <a:rPr lang="zh-CN" altLang="en-US" dirty="0" smtClean="0"/>
-              <a:t>、产生原因分析；</a:t>
-            </a:r>
-            <a:r>
-              <a:rPr lang="en-US" altLang="zh-CN" dirty="0" smtClean="0"/>
-              <a:t>2</a:t>
-            </a:r>
-            <a:r>
-              <a:rPr lang="zh-CN" altLang="en-US" dirty="0" smtClean="0"/>
-              <a:t>、流出原因分析；</a:t>
-            </a:r>
-            <a:r>
-              <a:rPr lang="en-US" altLang="zh-CN" dirty="0" smtClean="0"/>
-              <a:t>3</a:t>
-            </a:r>
-            <a:r>
-              <a:rPr lang="zh-CN" altLang="en-US" dirty="0" smtClean="0"/>
-              <a:t>、使用</a:t>
-            </a:r>
-            <a:r>
-              <a:rPr lang="en-US" altLang="zh-CN" dirty="0" smtClean="0"/>
-              <a:t>5WHY</a:t>
-            </a:r>
-            <a:r>
-              <a:rPr lang="zh-CN" altLang="en-US" dirty="0" smtClean="0"/>
-              <a:t>或鱼骨图等质量工具</a:t>
-            </a:r>
-            <a:endParaRPr lang="en-US" altLang="zh-CN" dirty="0" smtClean="0"/>
-          </a:p>
-          <a:p>
             <a:pPr lvl="0">
               <a:spcBef>
                 <a:spcPct val="0"/>
@@ -1066,7 +1014,7 @@
       </p:sp>
       <p:sp>
         <p:nvSpPr>
-          <p:cNvPr id="19459" name="灯片编号占位符 3"/>
+          <p:cNvPr id="25603" name="灯片编号占位符 3"/>
           <p:cNvSpPr>
             <a:spLocks noGrp="1"/>
           </p:cNvSpPr>
@@ -1132,7 +1080,7 @@
       </p:grpSpPr>
       <p:sp>
         <p:nvSpPr>
-          <p:cNvPr id="25601" name="幻灯片图像占位符 1"/>
+          <p:cNvPr id="29697" name="幻灯片图像占位符 1"/>
           <p:cNvSpPr>
             <a:spLocks noGrp="1" noRot="1" noChangeAspect="1"/>
           </p:cNvSpPr>
@@ -1144,7 +1092,7 @@
       </p:sp>
       <p:sp>
         <p:nvSpPr>
-          <p:cNvPr id="25602" name="备注占位符 2"/>
+          <p:cNvPr id="29698" name="备注占位符 2"/>
           <p:cNvSpPr>
             <a:spLocks noGrp="1"/>
           </p:cNvSpPr>
@@ -1168,7 +1116,7 @@
       </p:sp>
       <p:sp>
         <p:nvSpPr>
-          <p:cNvPr id="25603" name="灯片编号占位符 3"/>
+          <p:cNvPr id="29699" name="灯片编号占位符 3"/>
           <p:cNvSpPr>
             <a:spLocks noGrp="1"/>
           </p:cNvSpPr>
@@ -1336,108 +1284,6 @@
       </p:grpSpPr>
       <p:sp>
         <p:nvSpPr>
-          <p:cNvPr id="29697" name="幻灯片图像占位符 1"/>
-          <p:cNvSpPr>
-            <a:spLocks noGrp="1" noRot="1" noChangeAspect="1"/>
-          </p:cNvSpPr>
-          <p:nvPr>
-            <p:ph type="sldImg"/>
-          </p:nvPr>
-        </p:nvSpPr>
-        <p:spPr/>
-      </p:sp>
-      <p:sp>
-        <p:nvSpPr>
-          <p:cNvPr id="29698" name="备注占位符 2"/>
-          <p:cNvSpPr>
-            <a:spLocks noGrp="1"/>
-          </p:cNvSpPr>
-          <p:nvPr>
-            <p:ph type="body"/>
-          </p:nvPr>
-        </p:nvSpPr>
-        <p:spPr/>
-        <p:txBody>
-          <a:bodyPr wrap="square" lIns="91440" tIns="45720" rIns="91440" bIns="45720" anchor="t"/>
-          <a:lstStyle/>
-          <a:p>
-            <a:pPr lvl="0">
-              <a:spcBef>
-                <a:spcPct val="0"/>
-              </a:spcBef>
-            </a:pPr>
-            <a:endParaRPr lang="en-US" altLang="zh-CN" dirty="0"/>
-          </a:p>
-        </p:txBody>
-      </p:sp>
-      <p:sp>
-        <p:nvSpPr>
-          <p:cNvPr id="29699" name="灯片编号占位符 3"/>
-          <p:cNvSpPr>
-            <a:spLocks noGrp="1"/>
-          </p:cNvSpPr>
-          <p:nvPr>
-            <p:ph type="sldNum" sz="quarter"/>
-          </p:nvPr>
-        </p:nvSpPr>
-        <p:spPr>
-          <a:xfrm>
-            <a:off x="3849688" y="9428163"/>
-            <a:ext cx="2946400" cy="496887"/>
-          </a:xfrm>
-          <a:prstGeom prst="rect">
-            <a:avLst/>
-          </a:prstGeom>
-          <a:noFill/>
-          <a:ln w="9525">
-            <a:noFill/>
-          </a:ln>
-        </p:spPr>
-        <p:txBody>
-          <a:bodyPr vert="horz" wrap="square" lIns="91440" tIns="45720" rIns="91440" bIns="45720" anchor="b"/>
-          <a:lstStyle/>
-          <a:p>
-            <a:pPr lvl="0" algn="r"/>
-            <a:fld id="{9A0DB2DC-4C9A-4742-B13C-FB6460FD3503}" type="slidenum">
-              <a:rPr lang="en-US" altLang="zh-CN" sz="1200">
-                <a:latin typeface="Calibri" panose="020F0502020204030204" pitchFamily="34" charset="0"/>
-                <a:ea typeface="宋体" panose="02010600030101010101" pitchFamily="2" charset="-122"/>
-              </a:rPr>
-            </a:fld>
-            <a:endParaRPr lang="en-US" altLang="zh-CN" sz="1200">
-              <a:latin typeface="Calibri" panose="020F0502020204030204" pitchFamily="34" charset="0"/>
-              <a:ea typeface="宋体" panose="02010600030101010101" pitchFamily="2" charset="-122"/>
-            </a:endParaRPr>
-          </a:p>
-        </p:txBody>
-      </p:sp>
-    </p:spTree>
-  </p:cSld>
-  <p:clrMapOvr>
-    <a:masterClrMapping/>
-  </p:clrMapOvr>
-</p:notes>
-</file>
-
-<file path=ppt/notesSlides/notesSlide14.xml><?xml version="1.0" encoding="utf-8"?>
-<p:notes xmlns:a="http://schemas.openxmlformats.org/drawingml/2006/main" xmlns:r="http://schemas.openxmlformats.org/officeDocument/2006/relationships" xmlns:p="http://schemas.openxmlformats.org/presentationml/2006/main">
-  <p:cSld>
-    <p:spTree>
-      <p:nvGrpSpPr>
-        <p:cNvPr id="1" name=""/>
-        <p:cNvGrpSpPr/>
-        <p:nvPr/>
-      </p:nvGrpSpPr>
-      <p:grpSpPr>
-        <a:xfrm>
-          <a:off x="0" y="0"/>
-          <a:ext cx="0" cy="0"/>
-          <a:chOff x="0" y="0"/>
-          <a:chExt cx="0" cy="0"/>
-        </a:xfrm>
-      </p:grpSpPr>
-      <p:sp>
-        <p:nvSpPr>
           <p:cNvPr id="17409" name="幻灯片图像占位符 1"/>
           <p:cNvSpPr>
             <a:spLocks noGrp="1" noRot="1" noChangeAspect="1"/>
@@ -1521,7 +1367,7 @@
 </p:notes>
 </file>
 
-<file path=ppt/notesSlides/notesSlide15.xml><?xml version="1.0" encoding="utf-8"?>
+<file path=ppt/notesSlides/notesSlide14.xml><?xml version="1.0" encoding="utf-8"?>
 <p:notes xmlns:a="http://schemas.openxmlformats.org/drawingml/2006/main" xmlns:r="http://schemas.openxmlformats.org/officeDocument/2006/relationships" xmlns:p="http://schemas.openxmlformats.org/presentationml/2006/main">
   <p:cSld>
     <p:spTree>
@@ -4315,6 +4161,17 @@
               </a:rPr>
               <a:t>编制：</a:t>
             </a:r>
+            <a:r>
+              <a:rPr lang="en-US" sz="1400" dirty="0">
+                <a:solidFill>
+                  <a:srgbClr val="000000"/>
+                </a:solidFill>
+                <a:latin typeface="微软雅黑" panose="020B0503020204020204" pitchFamily="34" charset="-122"/>
+                <a:ea typeface="微软雅黑" panose="020B0503020204020204" pitchFamily="34" charset="-122"/>
+                <a:sym typeface="+mn-ea"/>
+              </a:rPr>
+              <a:t>{{content}}</a:t>
+            </a:r>
             <a:endParaRPr lang="en-US" altLang="zh-CN" sz="1400" dirty="0" smtClean="0">
               <a:latin typeface="微软雅黑" panose="020B0503020204020204" pitchFamily="34" charset="-122"/>
               <a:ea typeface="微软雅黑" panose="020B0503020204020204" pitchFamily="34" charset="-122"/>
@@ -4332,6 +4189,17 @@
                 <a:ea typeface="微软雅黑" panose="020B0503020204020204" pitchFamily="34" charset="-122"/>
               </a:rPr>
               <a:t>审核：</a:t>
+            </a:r>
+            <a:r>
+              <a:rPr lang="en-US" sz="1400" dirty="0">
+                <a:solidFill>
+                  <a:srgbClr val="000000"/>
+                </a:solidFill>
+                <a:latin typeface="微软雅黑" panose="020B0503020204020204" pitchFamily="34" charset="-122"/>
+                <a:ea typeface="微软雅黑" panose="020B0503020204020204" pitchFamily="34" charset="-122"/>
+                <a:sym typeface="+mn-ea"/>
+              </a:rPr>
+              <a:t>{{content}}</a:t>
             </a:r>
             <a:endParaRPr lang="en-US" altLang="zh-CN" sz="1400" dirty="0">
               <a:latin typeface="微软雅黑" panose="020B0503020204020204" pitchFamily="34" charset="-122"/>
@@ -4358,6 +4226,17 @@
               </a:rPr>
               <a:t>：</a:t>
             </a:r>
+            <a:r>
+              <a:rPr lang="en-US" sz="1400" dirty="0">
+                <a:solidFill>
+                  <a:srgbClr val="000000"/>
+                </a:solidFill>
+                <a:latin typeface="微软雅黑" panose="020B0503020204020204" pitchFamily="34" charset="-122"/>
+                <a:ea typeface="微软雅黑" panose="020B0503020204020204" pitchFamily="34" charset="-122"/>
+                <a:sym typeface="+mn-ea"/>
+              </a:rPr>
+              <a:t>{{content}}</a:t>
+            </a:r>
             <a:endParaRPr lang="en-US" altLang="zh-CN" sz="1400" dirty="0">
               <a:latin typeface="微软雅黑" panose="020B0503020204020204" pitchFamily="34" charset="-122"/>
               <a:ea typeface="微软雅黑" panose="020B0503020204020204" pitchFamily="34" charset="-122"/>
@@ -4375,6 +4254,17 @@
                 <a:ea typeface="微软雅黑" panose="020B0503020204020204" pitchFamily="34" charset="-122"/>
               </a:rPr>
               <a:t>日期：</a:t>
+            </a:r>
+            <a:r>
+              <a:rPr lang="en-US" sz="1400" dirty="0">
+                <a:solidFill>
+                  <a:srgbClr val="000000"/>
+                </a:solidFill>
+                <a:latin typeface="微软雅黑" panose="020B0503020204020204" pitchFamily="34" charset="-122"/>
+                <a:ea typeface="微软雅黑" panose="020B0503020204020204" pitchFamily="34" charset="-122"/>
+                <a:sym typeface="+mn-ea"/>
+              </a:rPr>
+              <a:t>{{content}}</a:t>
             </a:r>
             <a:endParaRPr lang="en-US" altLang="zh-CN" sz="1400" dirty="0" smtClean="0">
               <a:latin typeface="微软雅黑" panose="020B0503020204020204" pitchFamily="34" charset="-122"/>
@@ -4403,665 +4293,6 @@
 </file>
 
 <file path=ppt/slides/slide10.xml><?xml version="1.0" encoding="utf-8"?>
-<p:sld xmlns:a="http://schemas.openxmlformats.org/drawingml/2006/main" xmlns:r="http://schemas.openxmlformats.org/officeDocument/2006/relationships" xmlns:p="http://schemas.openxmlformats.org/presentationml/2006/main">
-  <p:cSld>
-    <p:spTree>
-      <p:nvGrpSpPr>
-        <p:cNvPr id="1" name=""/>
-        <p:cNvGrpSpPr/>
-        <p:nvPr/>
-      </p:nvGrpSpPr>
-      <p:grpSpPr>
-        <a:xfrm>
-          <a:off x="0" y="0"/>
-          <a:ext cx="0" cy="0"/>
-          <a:chOff x="0" y="0"/>
-          <a:chExt cx="0" cy="0"/>
-        </a:xfrm>
-      </p:grpSpPr>
-      <p:graphicFrame>
-        <p:nvGraphicFramePr>
-          <p:cNvPr id="9" name="表格 8"/>
-          <p:cNvGraphicFramePr/>
-          <p:nvPr>
-            <p:custDataLst>
-              <p:tags r:id="rId1"/>
-            </p:custDataLst>
-          </p:nvPr>
-        </p:nvGraphicFramePr>
-        <p:xfrm>
-          <a:off x="683260" y="1385570"/>
-          <a:ext cx="7987665" cy="3379470"/>
-        </p:xfrm>
-        <a:graphic>
-          <a:graphicData uri="http://schemas.openxmlformats.org/drawingml/2006/table">
-            <a:tbl>
-              <a:tblPr firstRow="1" bandRow="1">
-                <a:tableStyleId>{5940675A-B579-460E-94D1-54222C63F5DA}</a:tableStyleId>
-              </a:tblPr>
-              <a:tblGrid>
-                <a:gridCol w="633095"/>
-                <a:gridCol w="3912870"/>
-                <a:gridCol w="3441700"/>
-              </a:tblGrid>
-              <a:tr h="396000">
-                <a:tc>
-                  <a:txBody>
-                    <a:bodyPr/>
-                    <a:p>
-                      <a:pPr algn="ctr">
-                        <a:buNone/>
-                      </a:pPr>
-                      <a:r>
-                        <a:rPr lang="zh-CN" altLang="en-US" sz="1100" b="1" dirty="0">
-                          <a:effectLst/>
-                          <a:latin typeface="微软雅黑" panose="020B0503020204020204" pitchFamily="34" charset="-122"/>
-                          <a:ea typeface="微软雅黑" panose="020B0503020204020204" pitchFamily="34" charset="-122"/>
-                        </a:rPr>
-                        <a:t>层次</a:t>
-                      </a:r>
-                      <a:endParaRPr lang="zh-CN" altLang="en-US" sz="1100" b="1" dirty="0">
-                        <a:effectLst/>
-                        <a:latin typeface="微软雅黑" panose="020B0503020204020204" pitchFamily="34" charset="-122"/>
-                        <a:ea typeface="微软雅黑" panose="020B0503020204020204" pitchFamily="34" charset="-122"/>
-                      </a:endParaRPr>
-                    </a:p>
-                  </a:txBody>
-                  <a:tcPr anchor="ctr" anchorCtr="0">
-                    <a:solidFill>
-                      <a:schemeClr val="bg1">
-                        <a:lumMod val="85000"/>
-                      </a:schemeClr>
-                    </a:solidFill>
-                  </a:tcPr>
-                </a:tc>
-                <a:tc>
-                  <a:txBody>
-                    <a:bodyPr/>
-                    <a:p>
-                      <a:pPr algn="ctr">
-                        <a:buNone/>
-                      </a:pPr>
-                      <a:r>
-                        <a:rPr lang="zh-CN" altLang="en-US" sz="1100" b="1" dirty="0">
-                          <a:effectLst/>
-                          <a:latin typeface="微软雅黑" panose="020B0503020204020204" pitchFamily="34" charset="-122"/>
-                          <a:ea typeface="微软雅黑" panose="020B0503020204020204" pitchFamily="34" charset="-122"/>
-                        </a:rPr>
-                        <a:t>问题</a:t>
-                      </a:r>
-                      <a:endParaRPr lang="zh-CN" altLang="en-US" sz="1100" b="1" dirty="0">
-                        <a:effectLst/>
-                        <a:latin typeface="微软雅黑" panose="020B0503020204020204" pitchFamily="34" charset="-122"/>
-                        <a:ea typeface="微软雅黑" panose="020B0503020204020204" pitchFamily="34" charset="-122"/>
-                      </a:endParaRPr>
-                    </a:p>
-                  </a:txBody>
-                  <a:tcPr anchor="ctr" anchorCtr="0">
-                    <a:solidFill>
-                      <a:schemeClr val="bg1">
-                        <a:lumMod val="85000"/>
-                      </a:schemeClr>
-                    </a:solidFill>
-                  </a:tcPr>
-                </a:tc>
-                <a:tc>
-                  <a:txBody>
-                    <a:bodyPr/>
-                    <a:p>
-                      <a:pPr algn="ctr">
-                        <a:buNone/>
-                      </a:pPr>
-                      <a:r>
-                        <a:rPr lang="zh-CN" altLang="en-US" sz="1100" b="1" dirty="0">
-                          <a:effectLst/>
-                          <a:latin typeface="微软雅黑" panose="020B0503020204020204" pitchFamily="34" charset="-122"/>
-                          <a:ea typeface="微软雅黑" panose="020B0503020204020204" pitchFamily="34" charset="-122"/>
-                        </a:rPr>
-                        <a:t>原因</a:t>
-                      </a:r>
-                      <a:endParaRPr lang="zh-CN" altLang="en-US" sz="1100" b="1" dirty="0">
-                        <a:effectLst/>
-                        <a:latin typeface="微软雅黑" panose="020B0503020204020204" pitchFamily="34" charset="-122"/>
-                        <a:ea typeface="微软雅黑" panose="020B0503020204020204" pitchFamily="34" charset="-122"/>
-                      </a:endParaRPr>
-                    </a:p>
-                  </a:txBody>
-                  <a:tcPr anchor="ctr" anchorCtr="0">
-                    <a:solidFill>
-                      <a:schemeClr val="bg1">
-                        <a:lumMod val="85000"/>
-                      </a:schemeClr>
-                    </a:solidFill>
-                  </a:tcPr>
-                </a:tc>
-              </a:tr>
-              <a:tr h="396000">
-                <a:tc>
-                  <a:txBody>
-                    <a:bodyPr/>
-                    <a:p>
-                      <a:pPr algn="ctr">
-                        <a:buNone/>
-                      </a:pPr>
-                      <a:r>
-                        <a:rPr lang="en-US" altLang="zh-CN" sz="1000">
-                          <a:latin typeface="微软雅黑" panose="020B0503020204020204" pitchFamily="34" charset="-122"/>
-                          <a:ea typeface="微软雅黑" panose="020B0503020204020204" pitchFamily="34" charset="-122"/>
-                        </a:rPr>
-                        <a:t>Why1</a:t>
-                      </a:r>
-                      <a:endParaRPr lang="en-US" altLang="zh-CN" sz="1000">
-                        <a:latin typeface="微软雅黑" panose="020B0503020204020204" pitchFamily="34" charset="-122"/>
-                        <a:ea typeface="微软雅黑" panose="020B0503020204020204" pitchFamily="34" charset="-122"/>
-                      </a:endParaRPr>
-                    </a:p>
-                  </a:txBody>
-                  <a:tcPr anchor="ctr" anchorCtr="0"/>
-                </a:tc>
-                <a:tc>
-                  <a:txBody>
-                    <a:bodyPr/>
-                    <a:p>
-                      <a:pPr algn="ctr">
-                        <a:buNone/>
-                      </a:pPr>
-                      <a:endParaRPr lang="zh-CN" altLang="en-US" sz="1000">
-                        <a:latin typeface="微软雅黑" panose="020B0503020204020204" pitchFamily="34" charset="-122"/>
-                        <a:ea typeface="微软雅黑" panose="020B0503020204020204" pitchFamily="34" charset="-122"/>
-                      </a:endParaRPr>
-                    </a:p>
-                  </a:txBody>
-                  <a:tcPr anchor="ctr" anchorCtr="0"/>
-                </a:tc>
-                <a:tc>
-                  <a:txBody>
-                    <a:bodyPr/>
-                    <a:p>
-                      <a:pPr algn="ctr">
-                        <a:buNone/>
-                      </a:pPr>
-                      <a:endParaRPr lang="zh-CN" altLang="en-US" sz="1000">
-                        <a:latin typeface="微软雅黑" panose="020B0503020204020204" pitchFamily="34" charset="-122"/>
-                        <a:ea typeface="微软雅黑" panose="020B0503020204020204" pitchFamily="34" charset="-122"/>
-                      </a:endParaRPr>
-                    </a:p>
-                  </a:txBody>
-                  <a:tcPr anchor="ctr" anchorCtr="0"/>
-                </a:tc>
-              </a:tr>
-              <a:tr h="396000">
-                <a:tc>
-                  <a:txBody>
-                    <a:bodyPr/>
-                    <a:p>
-                      <a:pPr algn="ctr">
-                        <a:buNone/>
-                      </a:pPr>
-                      <a:r>
-                        <a:rPr lang="en-US" altLang="zh-CN" sz="1000">
-                          <a:latin typeface="微软雅黑" panose="020B0503020204020204" pitchFamily="34" charset="-122"/>
-                          <a:ea typeface="微软雅黑" panose="020B0503020204020204" pitchFamily="34" charset="-122"/>
-                          <a:sym typeface="+mn-ea"/>
-                        </a:rPr>
-                        <a:t>Why2</a:t>
-                      </a:r>
-                      <a:endParaRPr lang="zh-CN" altLang="en-US" sz="1000">
-                        <a:latin typeface="微软雅黑" panose="020B0503020204020204" pitchFamily="34" charset="-122"/>
-                        <a:ea typeface="微软雅黑" panose="020B0503020204020204" pitchFamily="34" charset="-122"/>
-                      </a:endParaRPr>
-                    </a:p>
-                  </a:txBody>
-                  <a:tcPr anchor="ctr" anchorCtr="0"/>
-                </a:tc>
-                <a:tc>
-                  <a:txBody>
-                    <a:bodyPr/>
-                    <a:p>
-                      <a:pPr algn="ctr">
-                        <a:buNone/>
-                      </a:pPr>
-                      <a:endParaRPr lang="zh-CN" altLang="en-US" sz="1000">
-                        <a:latin typeface="微软雅黑" panose="020B0503020204020204" pitchFamily="34" charset="-122"/>
-                        <a:ea typeface="微软雅黑" panose="020B0503020204020204" pitchFamily="34" charset="-122"/>
-                      </a:endParaRPr>
-                    </a:p>
-                  </a:txBody>
-                  <a:tcPr anchor="ctr" anchorCtr="0"/>
-                </a:tc>
-                <a:tc>
-                  <a:txBody>
-                    <a:bodyPr/>
-                    <a:p>
-                      <a:pPr algn="ctr">
-                        <a:buNone/>
-                      </a:pPr>
-                      <a:endParaRPr lang="zh-CN" altLang="en-US" sz="1000">
-                        <a:latin typeface="微软雅黑" panose="020B0503020204020204" pitchFamily="34" charset="-122"/>
-                        <a:ea typeface="微软雅黑" panose="020B0503020204020204" pitchFamily="34" charset="-122"/>
-                      </a:endParaRPr>
-                    </a:p>
-                  </a:txBody>
-                  <a:tcPr anchor="ctr" anchorCtr="0"/>
-                </a:tc>
-              </a:tr>
-              <a:tr h="396000">
-                <a:tc>
-                  <a:txBody>
-                    <a:bodyPr/>
-                    <a:p>
-                      <a:pPr algn="ctr">
-                        <a:buNone/>
-                      </a:pPr>
-                      <a:r>
-                        <a:rPr lang="en-US" altLang="zh-CN" sz="1000">
-                          <a:latin typeface="微软雅黑" panose="020B0503020204020204" pitchFamily="34" charset="-122"/>
-                          <a:ea typeface="微软雅黑" panose="020B0503020204020204" pitchFamily="34" charset="-122"/>
-                          <a:sym typeface="+mn-ea"/>
-                        </a:rPr>
-                        <a:t>Why3</a:t>
-                      </a:r>
-                      <a:endParaRPr lang="zh-CN" altLang="en-US" sz="1000">
-                        <a:latin typeface="微软雅黑" panose="020B0503020204020204" pitchFamily="34" charset="-122"/>
-                        <a:ea typeface="微软雅黑" panose="020B0503020204020204" pitchFamily="34" charset="-122"/>
-                      </a:endParaRPr>
-                    </a:p>
-                  </a:txBody>
-                  <a:tcPr anchor="ctr" anchorCtr="0"/>
-                </a:tc>
-                <a:tc>
-                  <a:txBody>
-                    <a:bodyPr/>
-                    <a:p>
-                      <a:pPr algn="ctr">
-                        <a:buNone/>
-                      </a:pPr>
-                      <a:endParaRPr lang="zh-CN" altLang="en-US" sz="1000">
-                        <a:latin typeface="微软雅黑" panose="020B0503020204020204" pitchFamily="34" charset="-122"/>
-                        <a:ea typeface="微软雅黑" panose="020B0503020204020204" pitchFamily="34" charset="-122"/>
-                      </a:endParaRPr>
-                    </a:p>
-                  </a:txBody>
-                  <a:tcPr anchor="ctr" anchorCtr="0"/>
-                </a:tc>
-                <a:tc>
-                  <a:txBody>
-                    <a:bodyPr/>
-                    <a:p>
-                      <a:pPr algn="ctr">
-                        <a:buNone/>
-                      </a:pPr>
-                      <a:endParaRPr lang="zh-CN" altLang="en-US" sz="1000">
-                        <a:latin typeface="微软雅黑" panose="020B0503020204020204" pitchFamily="34" charset="-122"/>
-                        <a:ea typeface="微软雅黑" panose="020B0503020204020204" pitchFamily="34" charset="-122"/>
-                      </a:endParaRPr>
-                    </a:p>
-                  </a:txBody>
-                  <a:tcPr anchor="ctr" anchorCtr="0"/>
-                </a:tc>
-              </a:tr>
-            </a:tbl>
-          </a:graphicData>
-        </a:graphic>
-      </p:graphicFrame>
-      <p:sp>
-        <p:nvSpPr>
-          <p:cNvPr id="18433" name="灯片编号占位符 1"/>
-          <p:cNvSpPr>
-            <a:spLocks noGrp="1"/>
-          </p:cNvSpPr>
-          <p:nvPr>
-            <p:ph type="sldNum" sz="quarter" idx="10"/>
-          </p:nvPr>
-        </p:nvSpPr>
-        <p:spPr>
-          <a:xfrm>
-            <a:off x="8388350" y="4691063"/>
-            <a:ext cx="360363" cy="112712"/>
-          </a:xfrm>
-          <a:noFill/>
-          <a:ln>
-            <a:noFill/>
-          </a:ln>
-        </p:spPr>
-        <p:txBody>
-          <a:bodyPr wrap="none" lIns="0" tIns="0" rIns="0" bIns="0" anchor="t"/>
-          <a:lstStyle>
-            <a:lvl1pPr marL="0" lvl="0" indent="0" algn="l" defTabSz="914400" rtl="0" eaLnBrk="1" fontAlgn="base" latinLnBrk="0" hangingPunct="1">
-              <a:lnSpc>
-                <a:spcPct val="100000"/>
-              </a:lnSpc>
-              <a:spcBef>
-                <a:spcPct val="0"/>
-              </a:spcBef>
-              <a:spcAft>
-                <a:spcPct val="0"/>
-              </a:spcAft>
-              <a:buNone/>
-              <a:defRPr sz="1800" kern="1200">
-                <a:solidFill>
-                  <a:schemeClr val="tx1"/>
-                </a:solidFill>
-                <a:latin typeface="Calibri" panose="020F0502020204030204" pitchFamily="34" charset="0"/>
-                <a:ea typeface="宋体" panose="02010600030101010101" pitchFamily="2" charset="-122"/>
-              </a:defRPr>
-            </a:lvl1pPr>
-            <a:lvl2pPr marL="457200" lvl="1" indent="0" algn="l" defTabSz="914400" rtl="0" eaLnBrk="1" fontAlgn="base" latinLnBrk="0" hangingPunct="1">
-              <a:lnSpc>
-                <a:spcPct val="100000"/>
-              </a:lnSpc>
-              <a:spcBef>
-                <a:spcPct val="0"/>
-              </a:spcBef>
-              <a:spcAft>
-                <a:spcPct val="0"/>
-              </a:spcAft>
-              <a:buFont typeface="Arial" panose="020B0604020202020204" pitchFamily="34" charset="0"/>
-              <a:buNone/>
-              <a:defRPr kern="1200">
-                <a:solidFill>
-                  <a:schemeClr val="tx1"/>
-                </a:solidFill>
-                <a:latin typeface="Calibri" panose="020F0502020204030204" pitchFamily="34" charset="0"/>
-                <a:ea typeface="宋体" panose="02010600030101010101" pitchFamily="2" charset="-122"/>
-                <a:cs typeface="+mn-cs"/>
-              </a:defRPr>
-            </a:lvl2pPr>
-            <a:lvl3pPr marL="914400" lvl="2" indent="0" algn="l" defTabSz="914400" rtl="0" eaLnBrk="1" fontAlgn="base" latinLnBrk="0" hangingPunct="1">
-              <a:lnSpc>
-                <a:spcPct val="100000"/>
-              </a:lnSpc>
-              <a:spcBef>
-                <a:spcPct val="0"/>
-              </a:spcBef>
-              <a:spcAft>
-                <a:spcPct val="0"/>
-              </a:spcAft>
-              <a:buFontTx/>
-              <a:buNone/>
-              <a:defRPr kern="1200">
-                <a:solidFill>
-                  <a:schemeClr val="tx1"/>
-                </a:solidFill>
-                <a:latin typeface="Calibri" panose="020F0502020204030204" pitchFamily="34" charset="0"/>
-                <a:ea typeface="宋体" panose="02010600030101010101" pitchFamily="2" charset="-122"/>
-                <a:cs typeface="+mn-cs"/>
-              </a:defRPr>
-            </a:lvl3pPr>
-            <a:lvl4pPr marL="1371600" lvl="3" indent="0" algn="l" defTabSz="914400" rtl="0" eaLnBrk="1" fontAlgn="base" latinLnBrk="0" hangingPunct="1">
-              <a:lnSpc>
-                <a:spcPct val="100000"/>
-              </a:lnSpc>
-              <a:spcBef>
-                <a:spcPct val="0"/>
-              </a:spcBef>
-              <a:spcAft>
-                <a:spcPct val="0"/>
-              </a:spcAft>
-              <a:buFont typeface="Arial" panose="020B0604020202020204" pitchFamily="34" charset="0"/>
-              <a:buNone/>
-              <a:defRPr kern="1200">
-                <a:solidFill>
-                  <a:schemeClr val="tx1"/>
-                </a:solidFill>
-                <a:latin typeface="Calibri" panose="020F0502020204030204" pitchFamily="34" charset="0"/>
-                <a:ea typeface="宋体" panose="02010600030101010101" pitchFamily="2" charset="-122"/>
-                <a:cs typeface="+mn-cs"/>
-              </a:defRPr>
-            </a:lvl4pPr>
-            <a:lvl5pPr marL="1828800" lvl="4" indent="0" algn="l" defTabSz="914400" rtl="0" eaLnBrk="1" fontAlgn="base" latinLnBrk="0" hangingPunct="1">
-              <a:lnSpc>
-                <a:spcPct val="100000"/>
-              </a:lnSpc>
-              <a:spcBef>
-                <a:spcPct val="0"/>
-              </a:spcBef>
-              <a:spcAft>
-                <a:spcPct val="0"/>
-              </a:spcAft>
-              <a:buFontTx/>
-              <a:buNone/>
-              <a:defRPr kern="1200">
-                <a:solidFill>
-                  <a:schemeClr val="tx1"/>
-                </a:solidFill>
-                <a:latin typeface="Calibri" panose="020F0502020204030204" pitchFamily="34" charset="0"/>
-                <a:ea typeface="宋体" panose="02010600030101010101" pitchFamily="2" charset="-122"/>
-                <a:cs typeface="+mn-cs"/>
-              </a:defRPr>
-            </a:lvl5pPr>
-          </a:lstStyle>
-          <a:p>
-            <a:pPr lvl="0" algn="r"/>
-            <a:fld id="{9A0DB2DC-4C9A-4742-B13C-FB6460FD3503}" type="slidenum">
-              <a:rPr lang="en-US" altLang="zh-CN" sz="1000" b="1">
-                <a:solidFill>
-                  <a:schemeClr val="bg1"/>
-                </a:solidFill>
-                <a:latin typeface="Arial" panose="020B0604020202020204" pitchFamily="34" charset="0"/>
-              </a:rPr>
-            </a:fld>
-            <a:endParaRPr lang="en-US" altLang="zh-CN" sz="1000" b="1">
-              <a:solidFill>
-                <a:schemeClr val="bg1"/>
-              </a:solidFill>
-              <a:latin typeface="Arial" panose="020B0604020202020204" pitchFamily="34" charset="0"/>
-            </a:endParaRPr>
-          </a:p>
-        </p:txBody>
-      </p:sp>
-      <p:grpSp>
-        <p:nvGrpSpPr>
-          <p:cNvPr id="3" name="组合 2"/>
-          <p:cNvGrpSpPr/>
-          <p:nvPr/>
-        </p:nvGrpSpPr>
-        <p:grpSpPr>
-          <a:xfrm>
-            <a:off x="467360" y="808990"/>
-            <a:ext cx="2835910" cy="245110"/>
-            <a:chOff x="736" y="1274"/>
-            <a:chExt cx="4466" cy="386"/>
-          </a:xfrm>
-        </p:grpSpPr>
-        <p:sp>
-          <p:nvSpPr>
-            <p:cNvPr id="4" name="TextBox 2"/>
-            <p:cNvSpPr/>
-            <p:nvPr/>
-          </p:nvSpPr>
-          <p:spPr>
-            <a:xfrm>
-              <a:off x="963" y="1274"/>
-              <a:ext cx="4239" cy="386"/>
-            </a:xfrm>
-            <a:prstGeom prst="rect">
-              <a:avLst/>
-            </a:prstGeom>
-            <a:noFill/>
-            <a:ln w="9525">
-              <a:noFill/>
-            </a:ln>
-          </p:spPr>
-          <p:txBody>
-            <a:bodyPr wrap="square" anchor="t">
-              <a:spAutoFit/>
-            </a:bodyPr>
-            <a:p>
-              <a:pPr>
-                <a:lnSpc>
-                  <a:spcPts val="1200"/>
-                </a:lnSpc>
-                <a:spcBef>
-                  <a:spcPts val="600"/>
-                </a:spcBef>
-              </a:pPr>
-              <a:r>
-                <a:rPr lang="en-US" altLang="zh-CN" sz="1400" b="1" dirty="0" smtClean="0">
-                  <a:solidFill>
-                    <a:srgbClr val="000000"/>
-                  </a:solidFill>
-                  <a:latin typeface="微软雅黑" panose="020B0503020204020204" pitchFamily="34" charset="-122"/>
-                  <a:ea typeface="微软雅黑" panose="020B0503020204020204" pitchFamily="34" charset="-122"/>
-                  <a:sym typeface="微软雅黑" panose="020B0503020204020204" pitchFamily="34" charset="-122"/>
-                </a:rPr>
-                <a:t>D4  </a:t>
-              </a:r>
-              <a:r>
-                <a:rPr lang="zh-CN" altLang="en-US" sz="1400" b="1" dirty="0" smtClean="0">
-                  <a:solidFill>
-                    <a:srgbClr val="000000"/>
-                  </a:solidFill>
-                  <a:latin typeface="微软雅黑" panose="020B0503020204020204" pitchFamily="34" charset="-122"/>
-                  <a:ea typeface="微软雅黑" panose="020B0503020204020204" pitchFamily="34" charset="-122"/>
-                  <a:sym typeface="微软雅黑" panose="020B0503020204020204" pitchFamily="34" charset="-122"/>
-                </a:rPr>
-                <a:t>原因</a:t>
-              </a:r>
-              <a:r>
-                <a:rPr lang="zh-CN" altLang="en-US" sz="1400" b="1" dirty="0">
-                  <a:solidFill>
-                    <a:srgbClr val="000000"/>
-                  </a:solidFill>
-                  <a:latin typeface="微软雅黑" panose="020B0503020204020204" pitchFamily="34" charset="-122"/>
-                  <a:ea typeface="微软雅黑" panose="020B0503020204020204" pitchFamily="34" charset="-122"/>
-                  <a:sym typeface="微软雅黑" panose="020B0503020204020204" pitchFamily="34" charset="-122"/>
-                </a:rPr>
-                <a:t>分析</a:t>
-              </a:r>
-              <a:endParaRPr lang="zh-CN" altLang="en-US" sz="1400" b="1">
-                <a:solidFill>
-                  <a:srgbClr val="000000"/>
-                </a:solidFill>
-                <a:latin typeface="微软雅黑" panose="020B0503020204020204" pitchFamily="34" charset="-122"/>
-                <a:ea typeface="微软雅黑" panose="020B0503020204020204" pitchFamily="34" charset="-122"/>
-                <a:sym typeface="微软雅黑" panose="020B0503020204020204" pitchFamily="34" charset="-122"/>
-              </a:endParaRPr>
-            </a:p>
-          </p:txBody>
-        </p:sp>
-        <p:sp>
-          <p:nvSpPr>
-            <p:cNvPr id="5" name="矩形 4"/>
-            <p:cNvSpPr/>
-            <p:nvPr/>
-          </p:nvSpPr>
-          <p:spPr>
-            <a:xfrm>
-              <a:off x="736" y="1313"/>
-              <a:ext cx="227" cy="229"/>
-            </a:xfrm>
-            <a:prstGeom prst="rect">
-              <a:avLst/>
-            </a:prstGeom>
-            <a:solidFill>
-              <a:srgbClr val="E62135"/>
-            </a:solidFill>
-            <a:ln w="9525">
-              <a:noFill/>
-            </a:ln>
-          </p:spPr>
-          <p:style>
-            <a:lnRef idx="1">
-              <a:schemeClr val="accent1"/>
-            </a:lnRef>
-            <a:fillRef idx="0">
-              <a:schemeClr val="accent1"/>
-            </a:fillRef>
-            <a:effectRef idx="0">
-              <a:schemeClr val="accent1"/>
-            </a:effectRef>
-            <a:fontRef idx="minor">
-              <a:schemeClr val="tx1"/>
-            </a:fontRef>
-          </p:style>
-          <p:txBody>
-            <a:bodyPr anchor="ctr"/>
-            <a:p>
-              <a:pPr algn="ctr" fontAlgn="auto">
-                <a:defRPr/>
-              </a:pPr>
-              <a:endParaRPr lang="zh-CN" altLang="en-US" sz="1600" noProof="1">
-                <a:solidFill>
-                  <a:srgbClr val="EBEBEB">
-                    <a:lumMod val="10000"/>
-                  </a:srgbClr>
-                </a:solidFill>
-              </a:endParaRPr>
-            </a:p>
-          </p:txBody>
-        </p:sp>
-      </p:grpSp>
-      <p:sp>
-        <p:nvSpPr>
-          <p:cNvPr id="7" name="文本框 6"/>
-          <p:cNvSpPr txBox="1"/>
-          <p:nvPr/>
-        </p:nvSpPr>
-        <p:spPr>
-          <a:xfrm>
-            <a:off x="611505" y="1059815"/>
-            <a:ext cx="3048000" cy="245110"/>
-          </a:xfrm>
-          <a:prstGeom prst="rect">
-            <a:avLst/>
-          </a:prstGeom>
-          <a:noFill/>
-        </p:spPr>
-        <p:txBody>
-          <a:bodyPr wrap="square" rtlCol="0">
-            <a:spAutoFit/>
-          </a:bodyPr>
-          <a:p>
-            <a:r>
-              <a:rPr lang="en-US" altLang="zh-CN" sz="1000">
-                <a:latin typeface="微软雅黑" panose="020B0503020204020204" pitchFamily="34" charset="-122"/>
-                <a:ea typeface="微软雅黑" panose="020B0503020204020204" pitchFamily="34" charset="-122"/>
-                <a:cs typeface="微软雅黑" panose="020B0503020204020204" pitchFamily="34" charset="-122"/>
-              </a:rPr>
-              <a:t>5WHY</a:t>
-            </a:r>
-            <a:r>
-              <a:rPr lang="zh-CN" altLang="en-US" sz="1000">
-                <a:latin typeface="微软雅黑" panose="020B0503020204020204" pitchFamily="34" charset="-122"/>
-                <a:ea typeface="微软雅黑" panose="020B0503020204020204" pitchFamily="34" charset="-122"/>
-                <a:cs typeface="微软雅黑" panose="020B0503020204020204" pitchFamily="34" charset="-122"/>
-              </a:rPr>
-              <a:t>流出</a:t>
-            </a:r>
-            <a:r>
-              <a:rPr lang="zh-CN" altLang="en-US" sz="1000">
-                <a:latin typeface="微软雅黑" panose="020B0503020204020204" pitchFamily="34" charset="-122"/>
-                <a:ea typeface="微软雅黑" panose="020B0503020204020204" pitchFamily="34" charset="-122"/>
-                <a:cs typeface="微软雅黑" panose="020B0503020204020204" pitchFamily="34" charset="-122"/>
-              </a:rPr>
-              <a:t>原因分析：</a:t>
-            </a:r>
-            <a:endParaRPr lang="zh-CN" altLang="en-US" sz="1000">
-              <a:latin typeface="微软雅黑" panose="020B0503020204020204" pitchFamily="34" charset="-122"/>
-              <a:ea typeface="微软雅黑" panose="020B0503020204020204" pitchFamily="34" charset="-122"/>
-              <a:cs typeface="微软雅黑" panose="020B0503020204020204" pitchFamily="34" charset="-122"/>
-            </a:endParaRPr>
-          </a:p>
-        </p:txBody>
-      </p:sp>
-    </p:spTree>
-  </p:cSld>
-  <p:clrMapOvr>
-    <a:masterClrMapping/>
-  </p:clrMapOvr>
-  <p:transition/>
-  <p:timing>
-    <p:tnLst>
-      <p:par>
-        <p:cTn id="1" dur="indefinite" restart="never" nodeType="tmRoot"/>
-      </p:par>
-    </p:tnLst>
-  </p:timing>
-</p:sld>
-</file>
-
-<file path=ppt/slides/slide11.xml><?xml version="1.0" encoding="utf-8"?>
 <p:sld xmlns:a="http://schemas.openxmlformats.org/drawingml/2006/main" xmlns:r="http://schemas.openxmlformats.org/officeDocument/2006/relationships" xmlns:p="http://schemas.openxmlformats.org/presentationml/2006/main">
   <p:cSld>
     <p:spTree>
@@ -6121,50 +5352,6 @@
           </p:txBody>
         </p:sp>
       </p:grpSp>
-      <p:pic>
-        <p:nvPicPr>
-          <p:cNvPr id="6" name="图片 5"/>
-          <p:cNvPicPr/>
-          <p:nvPr/>
-        </p:nvPicPr>
-        <p:blipFill>
-          <a:blip r:embed="rId1"/>
-          <a:stretch>
-            <a:fillRect/>
-          </a:stretch>
-        </p:blipFill>
-        <p:spPr>
-          <a:xfrm>
-            <a:off x="971550" y="2284095"/>
-            <a:ext cx="2692400" cy="1887220"/>
-          </a:xfrm>
-          <a:prstGeom prst="rect">
-            <a:avLst/>
-          </a:prstGeom>
-        </p:spPr>
-      </p:pic>
-      <p:pic>
-        <p:nvPicPr>
-          <p:cNvPr id="8" name="图片 7"/>
-          <p:cNvPicPr/>
-          <p:nvPr/>
-        </p:nvPicPr>
-        <p:blipFill>
-          <a:blip r:embed="rId1"/>
-          <a:stretch>
-            <a:fillRect/>
-          </a:stretch>
-        </p:blipFill>
-        <p:spPr>
-          <a:xfrm>
-            <a:off x="4716145" y="2284095"/>
-            <a:ext cx="2692400" cy="1887220"/>
-          </a:xfrm>
-          <a:prstGeom prst="rect">
-            <a:avLst/>
-          </a:prstGeom>
-        </p:spPr>
-      </p:pic>
     </p:spTree>
   </p:cSld>
   <p:clrMapOvr>
@@ -6181,7 +5368,7 @@
 </p:sld>
 </file>
 
-<file path=ppt/slides/slide12.xml><?xml version="1.0" encoding="utf-8"?>
+<file path=ppt/slides/slide11.xml><?xml version="1.0" encoding="utf-8"?>
 <p:sld xmlns:a="http://schemas.openxmlformats.org/drawingml/2006/main" xmlns:r="http://schemas.openxmlformats.org/officeDocument/2006/relationships" xmlns:p="http://schemas.openxmlformats.org/presentationml/2006/main">
   <p:cSld>
     <p:spTree>
@@ -7207,7 +6394,7 @@
 </p:sld>
 </file>
 
-<file path=ppt/slides/slide13.xml><?xml version="1.0" encoding="utf-8"?>
+<file path=ppt/slides/slide12.xml><?xml version="1.0" encoding="utf-8"?>
 <p:sld xmlns:a="http://schemas.openxmlformats.org/drawingml/2006/main" xmlns:r="http://schemas.openxmlformats.org/officeDocument/2006/relationships" xmlns:p="http://schemas.openxmlformats.org/presentationml/2006/main">
   <p:cSld>
     <p:spTree>
@@ -11708,7 +10895,7 @@
 </p:sld>
 </file>
 
-<file path=ppt/slides/slide14.xml><?xml version="1.0" encoding="utf-8"?>
+<file path=ppt/slides/slide13.xml><?xml version="1.0" encoding="utf-8"?>
 <p:sld xmlns:a="http://schemas.openxmlformats.org/drawingml/2006/main" xmlns:r="http://schemas.openxmlformats.org/officeDocument/2006/relationships" xmlns:p="http://schemas.openxmlformats.org/presentationml/2006/main">
   <p:cSld>
     <p:spTree>
@@ -11941,6 +11128,17 @@
                 <a:ea typeface="微软雅黑" panose="020B0503020204020204" pitchFamily="34" charset="-122"/>
                 <a:sym typeface="+mn-ea"/>
               </a:rPr>
+              <a:t>{{content}}</a:t>
+            </a:r>
+            <a:r>
+              <a:rPr lang="en-US" sz="1200" dirty="0">
+                <a:solidFill>
+                  <a:srgbClr val="000000"/>
+                </a:solidFill>
+                <a:latin typeface="微软雅黑" panose="020B0503020204020204" pitchFamily="34" charset="-122"/>
+                <a:ea typeface="微软雅黑" panose="020B0503020204020204" pitchFamily="34" charset="-122"/>
+                <a:sym typeface="+mn-ea"/>
+              </a:rPr>
               <a:t>  </a:t>
             </a:r>
             <a:endParaRPr sz="1200" dirty="0" smtClean="0">
@@ -11984,6 +11182,17 @@
                 <a:sym typeface="+mn-ea"/>
               </a:rPr>
               <a:t>：</a:t>
+            </a:r>
+            <a:r>
+              <a:rPr lang="en-US" sz="1200" dirty="0">
+                <a:solidFill>
+                  <a:srgbClr val="000000"/>
+                </a:solidFill>
+                <a:latin typeface="微软雅黑" panose="020B0503020204020204" pitchFamily="34" charset="-122"/>
+                <a:ea typeface="微软雅黑" panose="020B0503020204020204" pitchFamily="34" charset="-122"/>
+                <a:sym typeface="+mn-ea"/>
+              </a:rPr>
+              <a:t>{{content}}</a:t>
             </a:r>
             <a:r>
               <a:rPr lang="en-US" altLang="zh-CN" sz="1200" dirty="0">
@@ -12038,6 +11247,17 @@
               </a:rPr>
               <a:t>：</a:t>
             </a:r>
+            <a:r>
+              <a:rPr lang="en-US" sz="1200" dirty="0">
+                <a:solidFill>
+                  <a:srgbClr val="000000"/>
+                </a:solidFill>
+                <a:latin typeface="微软雅黑" panose="020B0503020204020204" pitchFamily="34" charset="-122"/>
+                <a:ea typeface="微软雅黑" panose="020B0503020204020204" pitchFamily="34" charset="-122"/>
+                <a:sym typeface="+mn-ea"/>
+              </a:rPr>
+              <a:t>{{content}}</a:t>
+            </a:r>
             <a:endParaRPr lang="en-US" altLang="zh-CN" sz="1200" dirty="0" smtClean="0">
               <a:latin typeface="微软雅黑" panose="020B0503020204020204" pitchFamily="34" charset="-122"/>
               <a:ea typeface="微软雅黑" panose="020B0503020204020204" pitchFamily="34" charset="-122"/>
@@ -12079,6 +11299,17 @@
                 <a:sym typeface="+mn-ea"/>
               </a:rPr>
               <a:t>：</a:t>
+            </a:r>
+            <a:r>
+              <a:rPr lang="en-US" sz="1200" dirty="0">
+                <a:solidFill>
+                  <a:srgbClr val="000000"/>
+                </a:solidFill>
+                <a:latin typeface="微软雅黑" panose="020B0503020204020204" pitchFamily="34" charset="-122"/>
+                <a:ea typeface="微软雅黑" panose="020B0503020204020204" pitchFamily="34" charset="-122"/>
+                <a:sym typeface="+mn-ea"/>
+              </a:rPr>
+              <a:t>{{content}}</a:t>
             </a:r>
             <a:endParaRPr lang="zh-CN" altLang="en-US" sz="1200" dirty="0">
               <a:latin typeface="微软雅黑" panose="020B0503020204020204" pitchFamily="34" charset="-122"/>
@@ -12234,7 +11465,7 @@
 </p:sld>
 </file>
 
-<file path=ppt/slides/slide15.xml><?xml version="1.0" encoding="utf-8"?>
+<file path=ppt/slides/slide14.xml><?xml version="1.0" encoding="utf-8"?>
 <p:sld xmlns:a="http://schemas.openxmlformats.org/drawingml/2006/main" xmlns:r="http://schemas.openxmlformats.org/officeDocument/2006/relationships" xmlns:p="http://schemas.openxmlformats.org/presentationml/2006/main">
   <p:cSld>
     <p:spTree>
@@ -14579,6 +13810,17 @@
                 </a:solidFill>
                 <a:latin typeface="微软雅黑" panose="020B0503020204020204" pitchFamily="34" charset="-122"/>
                 <a:ea typeface="微软雅黑" panose="020B0503020204020204" pitchFamily="34" charset="-122"/>
+                <a:sym typeface="+mn-ea"/>
+              </a:rPr>
+              <a:t>{{content}}</a:t>
+            </a:r>
+            <a:r>
+              <a:rPr lang="en-US" sz="1200" dirty="0">
+                <a:solidFill>
+                  <a:srgbClr val="000000"/>
+                </a:solidFill>
+                <a:latin typeface="微软雅黑" panose="020B0503020204020204" pitchFamily="34" charset="-122"/>
+                <a:ea typeface="微软雅黑" panose="020B0503020204020204" pitchFamily="34" charset="-122"/>
               </a:rPr>
               <a:t>  </a:t>
             </a:r>
@@ -14621,6 +13863,17 @@
                 <a:ea typeface="微软雅黑" panose="020B0503020204020204" pitchFamily="34" charset="-122"/>
               </a:rPr>
               <a:t>：</a:t>
+            </a:r>
+            <a:r>
+              <a:rPr lang="en-US" sz="1200" dirty="0">
+                <a:solidFill>
+                  <a:srgbClr val="000000"/>
+                </a:solidFill>
+                <a:latin typeface="微软雅黑" panose="020B0503020204020204" pitchFamily="34" charset="-122"/>
+                <a:ea typeface="微软雅黑" panose="020B0503020204020204" pitchFamily="34" charset="-122"/>
+                <a:sym typeface="+mn-ea"/>
+              </a:rPr>
+              <a:t>{{content}}</a:t>
             </a:r>
             <a:r>
               <a:rPr lang="en-US" altLang="zh-CN" sz="1200" dirty="0">
@@ -14689,6 +13942,17 @@
               </a:rPr>
               <a:t>：</a:t>
             </a:r>
+            <a:r>
+              <a:rPr lang="en-US" sz="1200" dirty="0">
+                <a:solidFill>
+                  <a:srgbClr val="000000"/>
+                </a:solidFill>
+                <a:latin typeface="微软雅黑" panose="020B0503020204020204" pitchFamily="34" charset="-122"/>
+                <a:ea typeface="微软雅黑" panose="020B0503020204020204" pitchFamily="34" charset="-122"/>
+                <a:sym typeface="+mn-ea"/>
+              </a:rPr>
+              <a:t>{{content}}</a:t>
+            </a:r>
             <a:endParaRPr lang="en-US" altLang="zh-CN" sz="1200" dirty="0" smtClean="0">
               <a:latin typeface="微软雅黑" panose="020B0503020204020204" pitchFamily="34" charset="-122"/>
               <a:ea typeface="微软雅黑" panose="020B0503020204020204" pitchFamily="34" charset="-122"/>
@@ -14728,6 +13992,17 @@
                 <a:ea typeface="微软雅黑" panose="020B0503020204020204" pitchFamily="34" charset="-122"/>
               </a:rPr>
               <a:t>：</a:t>
+            </a:r>
+            <a:r>
+              <a:rPr lang="en-US" sz="1200" dirty="0">
+                <a:solidFill>
+                  <a:srgbClr val="000000"/>
+                </a:solidFill>
+                <a:latin typeface="微软雅黑" panose="020B0503020204020204" pitchFamily="34" charset="-122"/>
+                <a:ea typeface="微软雅黑" panose="020B0503020204020204" pitchFamily="34" charset="-122"/>
+                <a:sym typeface="+mn-ea"/>
+              </a:rPr>
+              <a:t>{{content}}</a:t>
             </a:r>
             <a:endParaRPr lang="zh-CN" altLang="en-US" sz="1200" dirty="0" smtClean="0">
               <a:solidFill>
@@ -14771,6 +14046,17 @@
                 <a:ea typeface="微软雅黑" panose="020B0503020204020204" pitchFamily="34" charset="-122"/>
               </a:rPr>
               <a:t>：</a:t>
+            </a:r>
+            <a:r>
+              <a:rPr lang="en-US" sz="1200" dirty="0">
+                <a:solidFill>
+                  <a:srgbClr val="000000"/>
+                </a:solidFill>
+                <a:latin typeface="微软雅黑" panose="020B0503020204020204" pitchFamily="34" charset="-122"/>
+                <a:ea typeface="微软雅黑" panose="020B0503020204020204" pitchFamily="34" charset="-122"/>
+                <a:sym typeface="+mn-ea"/>
+              </a:rPr>
+              <a:t>{{content}}</a:t>
             </a:r>
             <a:endParaRPr sz="1200" dirty="0">
               <a:solidFill>
@@ -26791,61 +26077,6 @@
           </p:txBody>
         </p:sp>
       </p:grpSp>
-      <p:sp>
-        <p:nvSpPr>
-          <p:cNvPr id="12290" name="AI_DYNAMIC"/>
-          <p:cNvSpPr txBox="1"/>
-          <p:nvPr/>
-        </p:nvSpPr>
-        <p:spPr>
-          <a:xfrm>
-            <a:off x="502920" y="4599432"/>
-            <a:ext cx="8138160" cy="245110"/>
-          </a:xfrm>
-          <a:prstGeom prst="rect">
-            <a:avLst/>
-          </a:prstGeom>
-          <a:noFill/>
-        </p:spPr>
-        <p:txBody>
-          <a:bodyPr wrap="square">
-            <a:spAutoFit/>
-          </a:bodyPr>
-          <a:p>
-            <a:r>
-              <a:rPr lang="zh-CN" sz="1000">
-                <a:latin typeface="微软雅黑" panose="020B0503020204020204" pitchFamily="34" charset="-122"/>
-              </a:rPr>
-              <a:t>小结：此图片为示例图</a:t>
-            </a:r>
-            <a:endParaRPr sz="1000">
-              <a:latin typeface="微软雅黑" panose="020B0503020204020204" pitchFamily="34" charset="-122"/>
-            </a:endParaRPr>
-          </a:p>
-        </p:txBody>
-      </p:sp>
-      <p:pic>
-        <p:nvPicPr>
-          <p:cNvPr id="6" name="图片 5"/>
-          <p:cNvPicPr/>
-          <p:nvPr/>
-        </p:nvPicPr>
-        <p:blipFill>
-          <a:blip r:embed="rId1"/>
-          <a:stretch>
-            <a:fillRect/>
-          </a:stretch>
-        </p:blipFill>
-        <p:spPr>
-          <a:xfrm>
-            <a:off x="2242185" y="1193165"/>
-            <a:ext cx="4659630" cy="3266440"/>
-          </a:xfrm>
-          <a:prstGeom prst="rect">
-            <a:avLst/>
-          </a:prstGeom>
-        </p:spPr>
-      </p:pic>
     </p:spTree>
   </p:cSld>
   <p:clrMapOvr>
@@ -26863,410 +26094,6 @@
 </file>
 
 <file path=ppt/slides/slide8.xml><?xml version="1.0" encoding="utf-8"?>
-<p:sld xmlns:a="http://schemas.openxmlformats.org/drawingml/2006/main" xmlns:r="http://schemas.openxmlformats.org/officeDocument/2006/relationships" xmlns:p="http://schemas.openxmlformats.org/presentationml/2006/main">
-  <p:cSld>
-    <p:spTree>
-      <p:nvGrpSpPr>
-        <p:cNvPr id="1" name=""/>
-        <p:cNvGrpSpPr/>
-        <p:nvPr/>
-      </p:nvGrpSpPr>
-      <p:grpSpPr>
-        <a:xfrm>
-          <a:off x="0" y="0"/>
-          <a:ext cx="0" cy="0"/>
-          <a:chOff x="0" y="0"/>
-          <a:chExt cx="0" cy="0"/>
-        </a:xfrm>
-      </p:grpSpPr>
-      <p:sp>
-        <p:nvSpPr>
-          <p:cNvPr id="18433" name="灯片编号占位符 1"/>
-          <p:cNvSpPr>
-            <a:spLocks noGrp="1"/>
-          </p:cNvSpPr>
-          <p:nvPr>
-            <p:ph type="sldNum" sz="quarter" idx="10"/>
-          </p:nvPr>
-        </p:nvSpPr>
-        <p:spPr>
-          <a:xfrm>
-            <a:off x="8388350" y="4691063"/>
-            <a:ext cx="360363" cy="112712"/>
-          </a:xfrm>
-          <a:noFill/>
-          <a:ln>
-            <a:noFill/>
-          </a:ln>
-        </p:spPr>
-        <p:txBody>
-          <a:bodyPr wrap="none" lIns="0" tIns="0" rIns="0" bIns="0" anchor="t"/>
-          <a:lstStyle>
-            <a:lvl1pPr marL="0" lvl="0" indent="0" algn="l" defTabSz="914400" rtl="0" eaLnBrk="1" fontAlgn="base" latinLnBrk="0" hangingPunct="1">
-              <a:lnSpc>
-                <a:spcPct val="100000"/>
-              </a:lnSpc>
-              <a:spcBef>
-                <a:spcPct val="0"/>
-              </a:spcBef>
-              <a:spcAft>
-                <a:spcPct val="0"/>
-              </a:spcAft>
-              <a:buNone/>
-              <a:defRPr sz="1800" kern="1200">
-                <a:solidFill>
-                  <a:schemeClr val="tx1"/>
-                </a:solidFill>
-                <a:latin typeface="Calibri" panose="020F0502020204030204" pitchFamily="34" charset="0"/>
-                <a:ea typeface="宋体" panose="02010600030101010101" pitchFamily="2" charset="-122"/>
-              </a:defRPr>
-            </a:lvl1pPr>
-            <a:lvl2pPr marL="457200" lvl="1" indent="0" algn="l" defTabSz="914400" rtl="0" eaLnBrk="1" fontAlgn="base" latinLnBrk="0" hangingPunct="1">
-              <a:lnSpc>
-                <a:spcPct val="100000"/>
-              </a:lnSpc>
-              <a:spcBef>
-                <a:spcPct val="0"/>
-              </a:spcBef>
-              <a:spcAft>
-                <a:spcPct val="0"/>
-              </a:spcAft>
-              <a:buFont typeface="Arial" panose="020B0604020202020204" pitchFamily="34" charset="0"/>
-              <a:buNone/>
-              <a:defRPr kern="1200">
-                <a:solidFill>
-                  <a:schemeClr val="tx1"/>
-                </a:solidFill>
-                <a:latin typeface="Calibri" panose="020F0502020204030204" pitchFamily="34" charset="0"/>
-                <a:ea typeface="宋体" panose="02010600030101010101" pitchFamily="2" charset="-122"/>
-                <a:cs typeface="+mn-cs"/>
-              </a:defRPr>
-            </a:lvl2pPr>
-            <a:lvl3pPr marL="914400" lvl="2" indent="0" algn="l" defTabSz="914400" rtl="0" eaLnBrk="1" fontAlgn="base" latinLnBrk="0" hangingPunct="1">
-              <a:lnSpc>
-                <a:spcPct val="100000"/>
-              </a:lnSpc>
-              <a:spcBef>
-                <a:spcPct val="0"/>
-              </a:spcBef>
-              <a:spcAft>
-                <a:spcPct val="0"/>
-              </a:spcAft>
-              <a:buFontTx/>
-              <a:buNone/>
-              <a:defRPr kern="1200">
-                <a:solidFill>
-                  <a:schemeClr val="tx1"/>
-                </a:solidFill>
-                <a:latin typeface="Calibri" panose="020F0502020204030204" pitchFamily="34" charset="0"/>
-                <a:ea typeface="宋体" panose="02010600030101010101" pitchFamily="2" charset="-122"/>
-                <a:cs typeface="+mn-cs"/>
-              </a:defRPr>
-            </a:lvl3pPr>
-            <a:lvl4pPr marL="1371600" lvl="3" indent="0" algn="l" defTabSz="914400" rtl="0" eaLnBrk="1" fontAlgn="base" latinLnBrk="0" hangingPunct="1">
-              <a:lnSpc>
-                <a:spcPct val="100000"/>
-              </a:lnSpc>
-              <a:spcBef>
-                <a:spcPct val="0"/>
-              </a:spcBef>
-              <a:spcAft>
-                <a:spcPct val="0"/>
-              </a:spcAft>
-              <a:buFont typeface="Arial" panose="020B0604020202020204" pitchFamily="34" charset="0"/>
-              <a:buNone/>
-              <a:defRPr kern="1200">
-                <a:solidFill>
-                  <a:schemeClr val="tx1"/>
-                </a:solidFill>
-                <a:latin typeface="Calibri" panose="020F0502020204030204" pitchFamily="34" charset="0"/>
-                <a:ea typeface="宋体" panose="02010600030101010101" pitchFamily="2" charset="-122"/>
-                <a:cs typeface="+mn-cs"/>
-              </a:defRPr>
-            </a:lvl4pPr>
-            <a:lvl5pPr marL="1828800" lvl="4" indent="0" algn="l" defTabSz="914400" rtl="0" eaLnBrk="1" fontAlgn="base" latinLnBrk="0" hangingPunct="1">
-              <a:lnSpc>
-                <a:spcPct val="100000"/>
-              </a:lnSpc>
-              <a:spcBef>
-                <a:spcPct val="0"/>
-              </a:spcBef>
-              <a:spcAft>
-                <a:spcPct val="0"/>
-              </a:spcAft>
-              <a:buFontTx/>
-              <a:buNone/>
-              <a:defRPr kern="1200">
-                <a:solidFill>
-                  <a:schemeClr val="tx1"/>
-                </a:solidFill>
-                <a:latin typeface="Calibri" panose="020F0502020204030204" pitchFamily="34" charset="0"/>
-                <a:ea typeface="宋体" panose="02010600030101010101" pitchFamily="2" charset="-122"/>
-                <a:cs typeface="+mn-cs"/>
-              </a:defRPr>
-            </a:lvl5pPr>
-          </a:lstStyle>
-          <a:p>
-            <a:pPr lvl="0" algn="r"/>
-            <a:fld id="{9A0DB2DC-4C9A-4742-B13C-FB6460FD3503}" type="slidenum">
-              <a:rPr lang="en-US" altLang="zh-CN" sz="1000" b="1">
-                <a:solidFill>
-                  <a:schemeClr val="bg1"/>
-                </a:solidFill>
-                <a:latin typeface="Arial" panose="020B0604020202020204" pitchFamily="34" charset="0"/>
-              </a:rPr>
-            </a:fld>
-            <a:endParaRPr lang="en-US" altLang="zh-CN" sz="1000" b="1">
-              <a:solidFill>
-                <a:schemeClr val="bg1"/>
-              </a:solidFill>
-              <a:latin typeface="Arial" panose="020B0604020202020204" pitchFamily="34" charset="0"/>
-            </a:endParaRPr>
-          </a:p>
-        </p:txBody>
-      </p:sp>
-      <p:grpSp>
-        <p:nvGrpSpPr>
-          <p:cNvPr id="3" name="组合 2"/>
-          <p:cNvGrpSpPr/>
-          <p:nvPr/>
-        </p:nvGrpSpPr>
-        <p:grpSpPr>
-          <a:xfrm>
-            <a:off x="467360" y="808990"/>
-            <a:ext cx="2835910" cy="245110"/>
-            <a:chOff x="736" y="1274"/>
-            <a:chExt cx="4466" cy="386"/>
-          </a:xfrm>
-        </p:grpSpPr>
-        <p:sp>
-          <p:nvSpPr>
-            <p:cNvPr id="4" name="TextBox 2"/>
-            <p:cNvSpPr/>
-            <p:nvPr/>
-          </p:nvSpPr>
-          <p:spPr>
-            <a:xfrm>
-              <a:off x="963" y="1274"/>
-              <a:ext cx="4239" cy="386"/>
-            </a:xfrm>
-            <a:prstGeom prst="rect">
-              <a:avLst/>
-            </a:prstGeom>
-            <a:noFill/>
-            <a:ln w="9525">
-              <a:noFill/>
-            </a:ln>
-          </p:spPr>
-          <p:txBody>
-            <a:bodyPr wrap="square" anchor="t">
-              <a:spAutoFit/>
-            </a:bodyPr>
-            <a:p>
-              <a:pPr>
-                <a:lnSpc>
-                  <a:spcPts val="1200"/>
-                </a:lnSpc>
-                <a:spcBef>
-                  <a:spcPts val="600"/>
-                </a:spcBef>
-              </a:pPr>
-              <a:r>
-                <a:rPr lang="en-US" altLang="zh-CN" sz="1400" b="1" dirty="0" smtClean="0">
-                  <a:solidFill>
-                    <a:srgbClr val="000000"/>
-                  </a:solidFill>
-                  <a:latin typeface="微软雅黑" panose="020B0503020204020204" pitchFamily="34" charset="-122"/>
-                  <a:ea typeface="微软雅黑" panose="020B0503020204020204" pitchFamily="34" charset="-122"/>
-                  <a:sym typeface="微软雅黑" panose="020B0503020204020204" pitchFamily="34" charset="-122"/>
-                </a:rPr>
-                <a:t>D4  </a:t>
-              </a:r>
-              <a:r>
-                <a:rPr lang="zh-CN" altLang="en-US" sz="1400" b="1" dirty="0" smtClean="0">
-                  <a:solidFill>
-                    <a:srgbClr val="000000"/>
-                  </a:solidFill>
-                  <a:latin typeface="微软雅黑" panose="020B0503020204020204" pitchFamily="34" charset="-122"/>
-                  <a:ea typeface="微软雅黑" panose="020B0503020204020204" pitchFamily="34" charset="-122"/>
-                  <a:sym typeface="微软雅黑" panose="020B0503020204020204" pitchFamily="34" charset="-122"/>
-                </a:rPr>
-                <a:t>原因</a:t>
-              </a:r>
-              <a:r>
-                <a:rPr lang="zh-CN" altLang="en-US" sz="1400" b="1" dirty="0">
-                  <a:solidFill>
-                    <a:srgbClr val="000000"/>
-                  </a:solidFill>
-                  <a:latin typeface="微软雅黑" panose="020B0503020204020204" pitchFamily="34" charset="-122"/>
-                  <a:ea typeface="微软雅黑" panose="020B0503020204020204" pitchFamily="34" charset="-122"/>
-                  <a:sym typeface="微软雅黑" panose="020B0503020204020204" pitchFamily="34" charset="-122"/>
-                </a:rPr>
-                <a:t>分析</a:t>
-              </a:r>
-              <a:endParaRPr lang="zh-CN" altLang="en-US" sz="1400" b="1">
-                <a:solidFill>
-                  <a:srgbClr val="000000"/>
-                </a:solidFill>
-                <a:latin typeface="微软雅黑" panose="020B0503020204020204" pitchFamily="34" charset="-122"/>
-                <a:ea typeface="微软雅黑" panose="020B0503020204020204" pitchFamily="34" charset="-122"/>
-                <a:sym typeface="微软雅黑" panose="020B0503020204020204" pitchFamily="34" charset="-122"/>
-              </a:endParaRPr>
-            </a:p>
-          </p:txBody>
-        </p:sp>
-        <p:sp>
-          <p:nvSpPr>
-            <p:cNvPr id="5" name="矩形 4"/>
-            <p:cNvSpPr/>
-            <p:nvPr/>
-          </p:nvSpPr>
-          <p:spPr>
-            <a:xfrm>
-              <a:off x="736" y="1313"/>
-              <a:ext cx="227" cy="229"/>
-            </a:xfrm>
-            <a:prstGeom prst="rect">
-              <a:avLst/>
-            </a:prstGeom>
-            <a:solidFill>
-              <a:srgbClr val="E62135"/>
-            </a:solidFill>
-            <a:ln w="9525">
-              <a:noFill/>
-            </a:ln>
-          </p:spPr>
-          <p:style>
-            <a:lnRef idx="1">
-              <a:schemeClr val="accent1"/>
-            </a:lnRef>
-            <a:fillRef idx="0">
-              <a:schemeClr val="accent1"/>
-            </a:fillRef>
-            <a:effectRef idx="0">
-              <a:schemeClr val="accent1"/>
-            </a:effectRef>
-            <a:fontRef idx="minor">
-              <a:schemeClr val="tx1"/>
-            </a:fontRef>
-          </p:style>
-          <p:txBody>
-            <a:bodyPr anchor="ctr"/>
-            <a:p>
-              <a:pPr algn="ctr" fontAlgn="auto">
-                <a:defRPr/>
-              </a:pPr>
-              <a:endParaRPr lang="zh-CN" altLang="en-US" sz="1600" noProof="1">
-                <a:solidFill>
-                  <a:srgbClr val="EBEBEB">
-                    <a:lumMod val="10000"/>
-                  </a:srgbClr>
-                </a:solidFill>
-              </a:endParaRPr>
-            </a:p>
-          </p:txBody>
-        </p:sp>
-      </p:grpSp>
-      <p:sp>
-        <p:nvSpPr>
-          <p:cNvPr id="12290" name="AI_DYNAMIC"/>
-          <p:cNvSpPr txBox="1"/>
-          <p:nvPr/>
-        </p:nvSpPr>
-        <p:spPr>
-          <a:xfrm>
-            <a:off x="502920" y="4599432"/>
-            <a:ext cx="8138160" cy="245110"/>
-          </a:xfrm>
-          <a:prstGeom prst="rect">
-            <a:avLst/>
-          </a:prstGeom>
-          <a:noFill/>
-        </p:spPr>
-        <p:txBody>
-          <a:bodyPr wrap="square">
-            <a:spAutoFit/>
-          </a:bodyPr>
-          <a:p>
-            <a:r>
-              <a:rPr lang="zh-CN" sz="1000">
-                <a:latin typeface="微软雅黑" panose="020B0503020204020204" pitchFamily="34" charset="-122"/>
-              </a:rPr>
-              <a:t>小结：图一为示</a:t>
-            </a:r>
-            <a:r>
-              <a:rPr lang="zh-CN" altLang="en-US" sz="1000">
-                <a:latin typeface="微软雅黑" panose="020B0503020204020204" pitchFamily="34" charset="-122"/>
-              </a:rPr>
-              <a:t>例图，图二为示例图</a:t>
-            </a:r>
-            <a:endParaRPr lang="zh-CN" altLang="en-US" sz="1000">
-              <a:latin typeface="微软雅黑" panose="020B0503020204020204" pitchFamily="34" charset="-122"/>
-            </a:endParaRPr>
-          </a:p>
-        </p:txBody>
-      </p:sp>
-      <p:pic>
-        <p:nvPicPr>
-          <p:cNvPr id="6" name="图片 5"/>
-          <p:cNvPicPr/>
-          <p:nvPr/>
-        </p:nvPicPr>
-        <p:blipFill>
-          <a:blip r:embed="rId1"/>
-          <a:stretch>
-            <a:fillRect/>
-          </a:stretch>
-        </p:blipFill>
-        <p:spPr>
-          <a:xfrm>
-            <a:off x="1043305" y="1707515"/>
-            <a:ext cx="2692400" cy="1887220"/>
-          </a:xfrm>
-          <a:prstGeom prst="rect">
-            <a:avLst/>
-          </a:prstGeom>
-        </p:spPr>
-      </p:pic>
-      <p:pic>
-        <p:nvPicPr>
-          <p:cNvPr id="7" name="图片 6"/>
-          <p:cNvPicPr/>
-          <p:nvPr/>
-        </p:nvPicPr>
-        <p:blipFill>
-          <a:blip r:embed="rId1"/>
-          <a:stretch>
-            <a:fillRect/>
-          </a:stretch>
-        </p:blipFill>
-        <p:spPr>
-          <a:xfrm>
-            <a:off x="4572000" y="1707515"/>
-            <a:ext cx="2692400" cy="1887220"/>
-          </a:xfrm>
-          <a:prstGeom prst="rect">
-            <a:avLst/>
-          </a:prstGeom>
-        </p:spPr>
-      </p:pic>
-    </p:spTree>
-  </p:cSld>
-  <p:clrMapOvr>
-    <a:masterClrMapping/>
-  </p:clrMapOvr>
-  <p:transition/>
-  <p:timing>
-    <p:tnLst>
-      <p:par>
-        <p:cTn id="1" dur="indefinite" restart="never" nodeType="tmRoot"/>
-      </p:par>
-    </p:tnLst>
-  </p:timing>
-</p:sld>
-</file>
-
-<file path=ppt/slides/slide9.xml><?xml version="1.0" encoding="utf-8"?>
 <p:sld xmlns:a="http://schemas.openxmlformats.org/drawingml/2006/main" xmlns:r="http://schemas.openxmlformats.org/officeDocument/2006/relationships" xmlns:p="http://schemas.openxmlformats.org/presentationml/2006/main">
   <p:cSld>
     <p:spTree>
@@ -28002,6 +26829,665 @@
                 <a:cs typeface="微软雅黑" panose="020B0503020204020204" pitchFamily="34" charset="-122"/>
               </a:rPr>
               <a:t>发生原因分析：</a:t>
+            </a:r>
+            <a:endParaRPr lang="zh-CN" altLang="en-US" sz="1000">
+              <a:latin typeface="微软雅黑" panose="020B0503020204020204" pitchFamily="34" charset="-122"/>
+              <a:ea typeface="微软雅黑" panose="020B0503020204020204" pitchFamily="34" charset="-122"/>
+              <a:cs typeface="微软雅黑" panose="020B0503020204020204" pitchFamily="34" charset="-122"/>
+            </a:endParaRPr>
+          </a:p>
+        </p:txBody>
+      </p:sp>
+    </p:spTree>
+  </p:cSld>
+  <p:clrMapOvr>
+    <a:masterClrMapping/>
+  </p:clrMapOvr>
+  <p:transition/>
+  <p:timing>
+    <p:tnLst>
+      <p:par>
+        <p:cTn id="1" dur="indefinite" restart="never" nodeType="tmRoot"/>
+      </p:par>
+    </p:tnLst>
+  </p:timing>
+</p:sld>
+</file>
+
+<file path=ppt/slides/slide9.xml><?xml version="1.0" encoding="utf-8"?>
+<p:sld xmlns:a="http://schemas.openxmlformats.org/drawingml/2006/main" xmlns:r="http://schemas.openxmlformats.org/officeDocument/2006/relationships" xmlns:p="http://schemas.openxmlformats.org/presentationml/2006/main">
+  <p:cSld>
+    <p:spTree>
+      <p:nvGrpSpPr>
+        <p:cNvPr id="1" name=""/>
+        <p:cNvGrpSpPr/>
+        <p:nvPr/>
+      </p:nvGrpSpPr>
+      <p:grpSpPr>
+        <a:xfrm>
+          <a:off x="0" y="0"/>
+          <a:ext cx="0" cy="0"/>
+          <a:chOff x="0" y="0"/>
+          <a:chExt cx="0" cy="0"/>
+        </a:xfrm>
+      </p:grpSpPr>
+      <p:graphicFrame>
+        <p:nvGraphicFramePr>
+          <p:cNvPr id="9" name="表格 8"/>
+          <p:cNvGraphicFramePr/>
+          <p:nvPr>
+            <p:custDataLst>
+              <p:tags r:id="rId1"/>
+            </p:custDataLst>
+          </p:nvPr>
+        </p:nvGraphicFramePr>
+        <p:xfrm>
+          <a:off x="683260" y="1385570"/>
+          <a:ext cx="7987665" cy="3379470"/>
+        </p:xfrm>
+        <a:graphic>
+          <a:graphicData uri="http://schemas.openxmlformats.org/drawingml/2006/table">
+            <a:tbl>
+              <a:tblPr firstRow="1" bandRow="1">
+                <a:tableStyleId>{5940675A-B579-460E-94D1-54222C63F5DA}</a:tableStyleId>
+              </a:tblPr>
+              <a:tblGrid>
+                <a:gridCol w="633095"/>
+                <a:gridCol w="3912870"/>
+                <a:gridCol w="3441700"/>
+              </a:tblGrid>
+              <a:tr h="396000">
+                <a:tc>
+                  <a:txBody>
+                    <a:bodyPr/>
+                    <a:p>
+                      <a:pPr algn="ctr">
+                        <a:buNone/>
+                      </a:pPr>
+                      <a:r>
+                        <a:rPr lang="zh-CN" altLang="en-US" sz="1100" b="1" dirty="0">
+                          <a:effectLst/>
+                          <a:latin typeface="微软雅黑" panose="020B0503020204020204" pitchFamily="34" charset="-122"/>
+                          <a:ea typeface="微软雅黑" panose="020B0503020204020204" pitchFamily="34" charset="-122"/>
+                        </a:rPr>
+                        <a:t>层次</a:t>
+                      </a:r>
+                      <a:endParaRPr lang="zh-CN" altLang="en-US" sz="1100" b="1" dirty="0">
+                        <a:effectLst/>
+                        <a:latin typeface="微软雅黑" panose="020B0503020204020204" pitchFamily="34" charset="-122"/>
+                        <a:ea typeface="微软雅黑" panose="020B0503020204020204" pitchFamily="34" charset="-122"/>
+                      </a:endParaRPr>
+                    </a:p>
+                  </a:txBody>
+                  <a:tcPr anchor="ctr" anchorCtr="0">
+                    <a:solidFill>
+                      <a:schemeClr val="bg1">
+                        <a:lumMod val="85000"/>
+                      </a:schemeClr>
+                    </a:solidFill>
+                  </a:tcPr>
+                </a:tc>
+                <a:tc>
+                  <a:txBody>
+                    <a:bodyPr/>
+                    <a:p>
+                      <a:pPr algn="ctr">
+                        <a:buNone/>
+                      </a:pPr>
+                      <a:r>
+                        <a:rPr lang="zh-CN" altLang="en-US" sz="1100" b="1" dirty="0">
+                          <a:effectLst/>
+                          <a:latin typeface="微软雅黑" panose="020B0503020204020204" pitchFamily="34" charset="-122"/>
+                          <a:ea typeface="微软雅黑" panose="020B0503020204020204" pitchFamily="34" charset="-122"/>
+                        </a:rPr>
+                        <a:t>问题</a:t>
+                      </a:r>
+                      <a:endParaRPr lang="zh-CN" altLang="en-US" sz="1100" b="1" dirty="0">
+                        <a:effectLst/>
+                        <a:latin typeface="微软雅黑" panose="020B0503020204020204" pitchFamily="34" charset="-122"/>
+                        <a:ea typeface="微软雅黑" panose="020B0503020204020204" pitchFamily="34" charset="-122"/>
+                      </a:endParaRPr>
+                    </a:p>
+                  </a:txBody>
+                  <a:tcPr anchor="ctr" anchorCtr="0">
+                    <a:solidFill>
+                      <a:schemeClr val="bg1">
+                        <a:lumMod val="85000"/>
+                      </a:schemeClr>
+                    </a:solidFill>
+                  </a:tcPr>
+                </a:tc>
+                <a:tc>
+                  <a:txBody>
+                    <a:bodyPr/>
+                    <a:p>
+                      <a:pPr algn="ctr">
+                        <a:buNone/>
+                      </a:pPr>
+                      <a:r>
+                        <a:rPr lang="zh-CN" altLang="en-US" sz="1100" b="1" dirty="0">
+                          <a:effectLst/>
+                          <a:latin typeface="微软雅黑" panose="020B0503020204020204" pitchFamily="34" charset="-122"/>
+                          <a:ea typeface="微软雅黑" panose="020B0503020204020204" pitchFamily="34" charset="-122"/>
+                        </a:rPr>
+                        <a:t>原因</a:t>
+                      </a:r>
+                      <a:endParaRPr lang="zh-CN" altLang="en-US" sz="1100" b="1" dirty="0">
+                        <a:effectLst/>
+                        <a:latin typeface="微软雅黑" panose="020B0503020204020204" pitchFamily="34" charset="-122"/>
+                        <a:ea typeface="微软雅黑" panose="020B0503020204020204" pitchFamily="34" charset="-122"/>
+                      </a:endParaRPr>
+                    </a:p>
+                  </a:txBody>
+                  <a:tcPr anchor="ctr" anchorCtr="0">
+                    <a:solidFill>
+                      <a:schemeClr val="bg1">
+                        <a:lumMod val="85000"/>
+                      </a:schemeClr>
+                    </a:solidFill>
+                  </a:tcPr>
+                </a:tc>
+              </a:tr>
+              <a:tr h="396000">
+                <a:tc>
+                  <a:txBody>
+                    <a:bodyPr/>
+                    <a:p>
+                      <a:pPr algn="ctr">
+                        <a:buNone/>
+                      </a:pPr>
+                      <a:r>
+                        <a:rPr lang="en-US" altLang="zh-CN" sz="1000">
+                          <a:latin typeface="微软雅黑" panose="020B0503020204020204" pitchFamily="34" charset="-122"/>
+                          <a:ea typeface="微软雅黑" panose="020B0503020204020204" pitchFamily="34" charset="-122"/>
+                        </a:rPr>
+                        <a:t>Why1</a:t>
+                      </a:r>
+                      <a:endParaRPr lang="en-US" altLang="zh-CN" sz="1000">
+                        <a:latin typeface="微软雅黑" panose="020B0503020204020204" pitchFamily="34" charset="-122"/>
+                        <a:ea typeface="微软雅黑" panose="020B0503020204020204" pitchFamily="34" charset="-122"/>
+                      </a:endParaRPr>
+                    </a:p>
+                  </a:txBody>
+                  <a:tcPr anchor="ctr" anchorCtr="0"/>
+                </a:tc>
+                <a:tc>
+                  <a:txBody>
+                    <a:bodyPr/>
+                    <a:p>
+                      <a:pPr algn="ctr">
+                        <a:buNone/>
+                      </a:pPr>
+                      <a:endParaRPr lang="zh-CN" altLang="en-US" sz="1000">
+                        <a:latin typeface="微软雅黑" panose="020B0503020204020204" pitchFamily="34" charset="-122"/>
+                        <a:ea typeface="微软雅黑" panose="020B0503020204020204" pitchFamily="34" charset="-122"/>
+                      </a:endParaRPr>
+                    </a:p>
+                  </a:txBody>
+                  <a:tcPr anchor="ctr" anchorCtr="0"/>
+                </a:tc>
+                <a:tc>
+                  <a:txBody>
+                    <a:bodyPr/>
+                    <a:p>
+                      <a:pPr algn="ctr">
+                        <a:buNone/>
+                      </a:pPr>
+                      <a:endParaRPr lang="zh-CN" altLang="en-US" sz="1000">
+                        <a:latin typeface="微软雅黑" panose="020B0503020204020204" pitchFamily="34" charset="-122"/>
+                        <a:ea typeface="微软雅黑" panose="020B0503020204020204" pitchFamily="34" charset="-122"/>
+                      </a:endParaRPr>
+                    </a:p>
+                  </a:txBody>
+                  <a:tcPr anchor="ctr" anchorCtr="0"/>
+                </a:tc>
+              </a:tr>
+              <a:tr h="396000">
+                <a:tc>
+                  <a:txBody>
+                    <a:bodyPr/>
+                    <a:p>
+                      <a:pPr algn="ctr">
+                        <a:buNone/>
+                      </a:pPr>
+                      <a:r>
+                        <a:rPr lang="en-US" altLang="zh-CN" sz="1000">
+                          <a:latin typeface="微软雅黑" panose="020B0503020204020204" pitchFamily="34" charset="-122"/>
+                          <a:ea typeface="微软雅黑" panose="020B0503020204020204" pitchFamily="34" charset="-122"/>
+                          <a:sym typeface="+mn-ea"/>
+                        </a:rPr>
+                        <a:t>Why2</a:t>
+                      </a:r>
+                      <a:endParaRPr lang="zh-CN" altLang="en-US" sz="1000">
+                        <a:latin typeface="微软雅黑" panose="020B0503020204020204" pitchFamily="34" charset="-122"/>
+                        <a:ea typeface="微软雅黑" panose="020B0503020204020204" pitchFamily="34" charset="-122"/>
+                      </a:endParaRPr>
+                    </a:p>
+                  </a:txBody>
+                  <a:tcPr anchor="ctr" anchorCtr="0"/>
+                </a:tc>
+                <a:tc>
+                  <a:txBody>
+                    <a:bodyPr/>
+                    <a:p>
+                      <a:pPr algn="ctr">
+                        <a:buNone/>
+                      </a:pPr>
+                      <a:endParaRPr lang="zh-CN" altLang="en-US" sz="1000">
+                        <a:latin typeface="微软雅黑" panose="020B0503020204020204" pitchFamily="34" charset="-122"/>
+                        <a:ea typeface="微软雅黑" panose="020B0503020204020204" pitchFamily="34" charset="-122"/>
+                      </a:endParaRPr>
+                    </a:p>
+                  </a:txBody>
+                  <a:tcPr anchor="ctr" anchorCtr="0"/>
+                </a:tc>
+                <a:tc>
+                  <a:txBody>
+                    <a:bodyPr/>
+                    <a:p>
+                      <a:pPr algn="ctr">
+                        <a:buNone/>
+                      </a:pPr>
+                      <a:endParaRPr lang="zh-CN" altLang="en-US" sz="1000">
+                        <a:latin typeface="微软雅黑" panose="020B0503020204020204" pitchFamily="34" charset="-122"/>
+                        <a:ea typeface="微软雅黑" panose="020B0503020204020204" pitchFamily="34" charset="-122"/>
+                      </a:endParaRPr>
+                    </a:p>
+                  </a:txBody>
+                  <a:tcPr anchor="ctr" anchorCtr="0"/>
+                </a:tc>
+              </a:tr>
+              <a:tr h="396000">
+                <a:tc>
+                  <a:txBody>
+                    <a:bodyPr/>
+                    <a:p>
+                      <a:pPr algn="ctr">
+                        <a:buNone/>
+                      </a:pPr>
+                      <a:r>
+                        <a:rPr lang="en-US" altLang="zh-CN" sz="1000">
+                          <a:latin typeface="微软雅黑" panose="020B0503020204020204" pitchFamily="34" charset="-122"/>
+                          <a:ea typeface="微软雅黑" panose="020B0503020204020204" pitchFamily="34" charset="-122"/>
+                          <a:sym typeface="+mn-ea"/>
+                        </a:rPr>
+                        <a:t>Why3</a:t>
+                      </a:r>
+                      <a:endParaRPr lang="zh-CN" altLang="en-US" sz="1000">
+                        <a:latin typeface="微软雅黑" panose="020B0503020204020204" pitchFamily="34" charset="-122"/>
+                        <a:ea typeface="微软雅黑" panose="020B0503020204020204" pitchFamily="34" charset="-122"/>
+                      </a:endParaRPr>
+                    </a:p>
+                  </a:txBody>
+                  <a:tcPr anchor="ctr" anchorCtr="0"/>
+                </a:tc>
+                <a:tc>
+                  <a:txBody>
+                    <a:bodyPr/>
+                    <a:p>
+                      <a:pPr algn="ctr">
+                        <a:buNone/>
+                      </a:pPr>
+                      <a:endParaRPr lang="zh-CN" altLang="en-US" sz="1000">
+                        <a:latin typeface="微软雅黑" panose="020B0503020204020204" pitchFamily="34" charset="-122"/>
+                        <a:ea typeface="微软雅黑" panose="020B0503020204020204" pitchFamily="34" charset="-122"/>
+                      </a:endParaRPr>
+                    </a:p>
+                  </a:txBody>
+                  <a:tcPr anchor="ctr" anchorCtr="0"/>
+                </a:tc>
+                <a:tc>
+                  <a:txBody>
+                    <a:bodyPr/>
+                    <a:p>
+                      <a:pPr algn="ctr">
+                        <a:buNone/>
+                      </a:pPr>
+                      <a:endParaRPr lang="zh-CN" altLang="en-US" sz="1000">
+                        <a:latin typeface="微软雅黑" panose="020B0503020204020204" pitchFamily="34" charset="-122"/>
+                        <a:ea typeface="微软雅黑" panose="020B0503020204020204" pitchFamily="34" charset="-122"/>
+                      </a:endParaRPr>
+                    </a:p>
+                  </a:txBody>
+                  <a:tcPr anchor="ctr" anchorCtr="0"/>
+                </a:tc>
+              </a:tr>
+            </a:tbl>
+          </a:graphicData>
+        </a:graphic>
+      </p:graphicFrame>
+      <p:sp>
+        <p:nvSpPr>
+          <p:cNvPr id="18433" name="灯片编号占位符 1"/>
+          <p:cNvSpPr>
+            <a:spLocks noGrp="1"/>
+          </p:cNvSpPr>
+          <p:nvPr>
+            <p:ph type="sldNum" sz="quarter" idx="10"/>
+          </p:nvPr>
+        </p:nvSpPr>
+        <p:spPr>
+          <a:xfrm>
+            <a:off x="8388350" y="4691063"/>
+            <a:ext cx="360363" cy="112712"/>
+          </a:xfrm>
+          <a:noFill/>
+          <a:ln>
+            <a:noFill/>
+          </a:ln>
+        </p:spPr>
+        <p:txBody>
+          <a:bodyPr wrap="none" lIns="0" tIns="0" rIns="0" bIns="0" anchor="t"/>
+          <a:lstStyle>
+            <a:lvl1pPr marL="0" lvl="0" indent="0" algn="l" defTabSz="914400" rtl="0" eaLnBrk="1" fontAlgn="base" latinLnBrk="0" hangingPunct="1">
+              <a:lnSpc>
+                <a:spcPct val="100000"/>
+              </a:lnSpc>
+              <a:spcBef>
+                <a:spcPct val="0"/>
+              </a:spcBef>
+              <a:spcAft>
+                <a:spcPct val="0"/>
+              </a:spcAft>
+              <a:buNone/>
+              <a:defRPr sz="1800" kern="1200">
+                <a:solidFill>
+                  <a:schemeClr val="tx1"/>
+                </a:solidFill>
+                <a:latin typeface="Calibri" panose="020F0502020204030204" pitchFamily="34" charset="0"/>
+                <a:ea typeface="宋体" panose="02010600030101010101" pitchFamily="2" charset="-122"/>
+              </a:defRPr>
+            </a:lvl1pPr>
+            <a:lvl2pPr marL="457200" lvl="1" indent="0" algn="l" defTabSz="914400" rtl="0" eaLnBrk="1" fontAlgn="base" latinLnBrk="0" hangingPunct="1">
+              <a:lnSpc>
+                <a:spcPct val="100000"/>
+              </a:lnSpc>
+              <a:spcBef>
+                <a:spcPct val="0"/>
+              </a:spcBef>
+              <a:spcAft>
+                <a:spcPct val="0"/>
+              </a:spcAft>
+              <a:buFont typeface="Arial" panose="020B0604020202020204" pitchFamily="34" charset="0"/>
+              <a:buNone/>
+              <a:defRPr kern="1200">
+                <a:solidFill>
+                  <a:schemeClr val="tx1"/>
+                </a:solidFill>
+                <a:latin typeface="Calibri" panose="020F0502020204030204" pitchFamily="34" charset="0"/>
+                <a:ea typeface="宋体" panose="02010600030101010101" pitchFamily="2" charset="-122"/>
+                <a:cs typeface="+mn-cs"/>
+              </a:defRPr>
+            </a:lvl2pPr>
+            <a:lvl3pPr marL="914400" lvl="2" indent="0" algn="l" defTabSz="914400" rtl="0" eaLnBrk="1" fontAlgn="base" latinLnBrk="0" hangingPunct="1">
+              <a:lnSpc>
+                <a:spcPct val="100000"/>
+              </a:lnSpc>
+              <a:spcBef>
+                <a:spcPct val="0"/>
+              </a:spcBef>
+              <a:spcAft>
+                <a:spcPct val="0"/>
+              </a:spcAft>
+              <a:buFontTx/>
+              <a:buNone/>
+              <a:defRPr kern="1200">
+                <a:solidFill>
+                  <a:schemeClr val="tx1"/>
+                </a:solidFill>
+                <a:latin typeface="Calibri" panose="020F0502020204030204" pitchFamily="34" charset="0"/>
+                <a:ea typeface="宋体" panose="02010600030101010101" pitchFamily="2" charset="-122"/>
+                <a:cs typeface="+mn-cs"/>
+              </a:defRPr>
+            </a:lvl3pPr>
+            <a:lvl4pPr marL="1371600" lvl="3" indent="0" algn="l" defTabSz="914400" rtl="0" eaLnBrk="1" fontAlgn="base" latinLnBrk="0" hangingPunct="1">
+              <a:lnSpc>
+                <a:spcPct val="100000"/>
+              </a:lnSpc>
+              <a:spcBef>
+                <a:spcPct val="0"/>
+              </a:spcBef>
+              <a:spcAft>
+                <a:spcPct val="0"/>
+              </a:spcAft>
+              <a:buFont typeface="Arial" panose="020B0604020202020204" pitchFamily="34" charset="0"/>
+              <a:buNone/>
+              <a:defRPr kern="1200">
+                <a:solidFill>
+                  <a:schemeClr val="tx1"/>
+                </a:solidFill>
+                <a:latin typeface="Calibri" panose="020F0502020204030204" pitchFamily="34" charset="0"/>
+                <a:ea typeface="宋体" panose="02010600030101010101" pitchFamily="2" charset="-122"/>
+                <a:cs typeface="+mn-cs"/>
+              </a:defRPr>
+            </a:lvl4pPr>
+            <a:lvl5pPr marL="1828800" lvl="4" indent="0" algn="l" defTabSz="914400" rtl="0" eaLnBrk="1" fontAlgn="base" latinLnBrk="0" hangingPunct="1">
+              <a:lnSpc>
+                <a:spcPct val="100000"/>
+              </a:lnSpc>
+              <a:spcBef>
+                <a:spcPct val="0"/>
+              </a:spcBef>
+              <a:spcAft>
+                <a:spcPct val="0"/>
+              </a:spcAft>
+              <a:buFontTx/>
+              <a:buNone/>
+              <a:defRPr kern="1200">
+                <a:solidFill>
+                  <a:schemeClr val="tx1"/>
+                </a:solidFill>
+                <a:latin typeface="Calibri" panose="020F0502020204030204" pitchFamily="34" charset="0"/>
+                <a:ea typeface="宋体" panose="02010600030101010101" pitchFamily="2" charset="-122"/>
+                <a:cs typeface="+mn-cs"/>
+              </a:defRPr>
+            </a:lvl5pPr>
+          </a:lstStyle>
+          <a:p>
+            <a:pPr lvl="0" algn="r"/>
+            <a:fld id="{9A0DB2DC-4C9A-4742-B13C-FB6460FD3503}" type="slidenum">
+              <a:rPr lang="en-US" altLang="zh-CN" sz="1000" b="1">
+                <a:solidFill>
+                  <a:schemeClr val="bg1"/>
+                </a:solidFill>
+                <a:latin typeface="Arial" panose="020B0604020202020204" pitchFamily="34" charset="0"/>
+              </a:rPr>
+            </a:fld>
+            <a:endParaRPr lang="en-US" altLang="zh-CN" sz="1000" b="1">
+              <a:solidFill>
+                <a:schemeClr val="bg1"/>
+              </a:solidFill>
+              <a:latin typeface="Arial" panose="020B0604020202020204" pitchFamily="34" charset="0"/>
+            </a:endParaRPr>
+          </a:p>
+        </p:txBody>
+      </p:sp>
+      <p:grpSp>
+        <p:nvGrpSpPr>
+          <p:cNvPr id="3" name="组合 2"/>
+          <p:cNvGrpSpPr/>
+          <p:nvPr/>
+        </p:nvGrpSpPr>
+        <p:grpSpPr>
+          <a:xfrm>
+            <a:off x="467360" y="808990"/>
+            <a:ext cx="2835910" cy="245110"/>
+            <a:chOff x="736" y="1274"/>
+            <a:chExt cx="4466" cy="386"/>
+          </a:xfrm>
+        </p:grpSpPr>
+        <p:sp>
+          <p:nvSpPr>
+            <p:cNvPr id="4" name="TextBox 2"/>
+            <p:cNvSpPr/>
+            <p:nvPr/>
+          </p:nvSpPr>
+          <p:spPr>
+            <a:xfrm>
+              <a:off x="963" y="1274"/>
+              <a:ext cx="4239" cy="386"/>
+            </a:xfrm>
+            <a:prstGeom prst="rect">
+              <a:avLst/>
+            </a:prstGeom>
+            <a:noFill/>
+            <a:ln w="9525">
+              <a:noFill/>
+            </a:ln>
+          </p:spPr>
+          <p:txBody>
+            <a:bodyPr wrap="square" anchor="t">
+              <a:spAutoFit/>
+            </a:bodyPr>
+            <a:p>
+              <a:pPr>
+                <a:lnSpc>
+                  <a:spcPts val="1200"/>
+                </a:lnSpc>
+                <a:spcBef>
+                  <a:spcPts val="600"/>
+                </a:spcBef>
+              </a:pPr>
+              <a:r>
+                <a:rPr lang="en-US" altLang="zh-CN" sz="1400" b="1" dirty="0" smtClean="0">
+                  <a:solidFill>
+                    <a:srgbClr val="000000"/>
+                  </a:solidFill>
+                  <a:latin typeface="微软雅黑" panose="020B0503020204020204" pitchFamily="34" charset="-122"/>
+                  <a:ea typeface="微软雅黑" panose="020B0503020204020204" pitchFamily="34" charset="-122"/>
+                  <a:sym typeface="微软雅黑" panose="020B0503020204020204" pitchFamily="34" charset="-122"/>
+                </a:rPr>
+                <a:t>D4  </a:t>
+              </a:r>
+              <a:r>
+                <a:rPr lang="zh-CN" altLang="en-US" sz="1400" b="1" dirty="0" smtClean="0">
+                  <a:solidFill>
+                    <a:srgbClr val="000000"/>
+                  </a:solidFill>
+                  <a:latin typeface="微软雅黑" panose="020B0503020204020204" pitchFamily="34" charset="-122"/>
+                  <a:ea typeface="微软雅黑" panose="020B0503020204020204" pitchFamily="34" charset="-122"/>
+                  <a:sym typeface="微软雅黑" panose="020B0503020204020204" pitchFamily="34" charset="-122"/>
+                </a:rPr>
+                <a:t>原因</a:t>
+              </a:r>
+              <a:r>
+                <a:rPr lang="zh-CN" altLang="en-US" sz="1400" b="1" dirty="0">
+                  <a:solidFill>
+                    <a:srgbClr val="000000"/>
+                  </a:solidFill>
+                  <a:latin typeface="微软雅黑" panose="020B0503020204020204" pitchFamily="34" charset="-122"/>
+                  <a:ea typeface="微软雅黑" panose="020B0503020204020204" pitchFamily="34" charset="-122"/>
+                  <a:sym typeface="微软雅黑" panose="020B0503020204020204" pitchFamily="34" charset="-122"/>
+                </a:rPr>
+                <a:t>分析</a:t>
+              </a:r>
+              <a:endParaRPr lang="zh-CN" altLang="en-US" sz="1400" b="1">
+                <a:solidFill>
+                  <a:srgbClr val="000000"/>
+                </a:solidFill>
+                <a:latin typeface="微软雅黑" panose="020B0503020204020204" pitchFamily="34" charset="-122"/>
+                <a:ea typeface="微软雅黑" panose="020B0503020204020204" pitchFamily="34" charset="-122"/>
+                <a:sym typeface="微软雅黑" panose="020B0503020204020204" pitchFamily="34" charset="-122"/>
+              </a:endParaRPr>
+            </a:p>
+          </p:txBody>
+        </p:sp>
+        <p:sp>
+          <p:nvSpPr>
+            <p:cNvPr id="5" name="矩形 4"/>
+            <p:cNvSpPr/>
+            <p:nvPr/>
+          </p:nvSpPr>
+          <p:spPr>
+            <a:xfrm>
+              <a:off x="736" y="1313"/>
+              <a:ext cx="227" cy="229"/>
+            </a:xfrm>
+            <a:prstGeom prst="rect">
+              <a:avLst/>
+            </a:prstGeom>
+            <a:solidFill>
+              <a:srgbClr val="E62135"/>
+            </a:solidFill>
+            <a:ln w="9525">
+              <a:noFill/>
+            </a:ln>
+          </p:spPr>
+          <p:style>
+            <a:lnRef idx="1">
+              <a:schemeClr val="accent1"/>
+            </a:lnRef>
+            <a:fillRef idx="0">
+              <a:schemeClr val="accent1"/>
+            </a:fillRef>
+            <a:effectRef idx="0">
+              <a:schemeClr val="accent1"/>
+            </a:effectRef>
+            <a:fontRef idx="minor">
+              <a:schemeClr val="tx1"/>
+            </a:fontRef>
+          </p:style>
+          <p:txBody>
+            <a:bodyPr anchor="ctr"/>
+            <a:p>
+              <a:pPr algn="ctr" fontAlgn="auto">
+                <a:defRPr/>
+              </a:pPr>
+              <a:endParaRPr lang="zh-CN" altLang="en-US" sz="1600" noProof="1">
+                <a:solidFill>
+                  <a:srgbClr val="EBEBEB">
+                    <a:lumMod val="10000"/>
+                  </a:srgbClr>
+                </a:solidFill>
+              </a:endParaRPr>
+            </a:p>
+          </p:txBody>
+        </p:sp>
+      </p:grpSp>
+      <p:sp>
+        <p:nvSpPr>
+          <p:cNvPr id="7" name="文本框 6"/>
+          <p:cNvSpPr txBox="1"/>
+          <p:nvPr/>
+        </p:nvSpPr>
+        <p:spPr>
+          <a:xfrm>
+            <a:off x="611505" y="1059815"/>
+            <a:ext cx="3048000" cy="245110"/>
+          </a:xfrm>
+          <a:prstGeom prst="rect">
+            <a:avLst/>
+          </a:prstGeom>
+          <a:noFill/>
+        </p:spPr>
+        <p:txBody>
+          <a:bodyPr wrap="square" rtlCol="0">
+            <a:spAutoFit/>
+          </a:bodyPr>
+          <a:p>
+            <a:r>
+              <a:rPr lang="en-US" altLang="zh-CN" sz="1000">
+                <a:latin typeface="微软雅黑" panose="020B0503020204020204" pitchFamily="34" charset="-122"/>
+                <a:ea typeface="微软雅黑" panose="020B0503020204020204" pitchFamily="34" charset="-122"/>
+                <a:cs typeface="微软雅黑" panose="020B0503020204020204" pitchFamily="34" charset="-122"/>
+              </a:rPr>
+              <a:t>5WHY</a:t>
+            </a:r>
+            <a:r>
+              <a:rPr lang="zh-CN" altLang="en-US" sz="1000">
+                <a:latin typeface="微软雅黑" panose="020B0503020204020204" pitchFamily="34" charset="-122"/>
+                <a:ea typeface="微软雅黑" panose="020B0503020204020204" pitchFamily="34" charset="-122"/>
+                <a:cs typeface="微软雅黑" panose="020B0503020204020204" pitchFamily="34" charset="-122"/>
+              </a:rPr>
+              <a:t>流出</a:t>
+            </a:r>
+            <a:r>
+              <a:rPr lang="zh-CN" altLang="en-US" sz="1000">
+                <a:latin typeface="微软雅黑" panose="020B0503020204020204" pitchFamily="34" charset="-122"/>
+                <a:ea typeface="微软雅黑" panose="020B0503020204020204" pitchFamily="34" charset="-122"/>
+                <a:cs typeface="微软雅黑" panose="020B0503020204020204" pitchFamily="34" charset="-122"/>
+              </a:rPr>
+              <a:t>原因分析：</a:t>
             </a:r>
             <a:endParaRPr lang="zh-CN" altLang="en-US" sz="1000">
               <a:latin typeface="微软雅黑" panose="020B0503020204020204" pitchFamily="34" charset="-122"/>

</xml_diff>

<commit_message>
chore: update template and secure API key
</commit_message>
<xml_diff>
--- a/8D模板.pptx
+++ b/8D模板.pptx
@@ -11098,7 +11098,7 @@
               <a:defRPr/>
             </a:pPr>
             <a:r>
-              <a:rPr lang="zh-CN" sz="1200" dirty="0">
+              <a:rPr lang="zh-CN" altLang="en-US" sz="1200" b="1" dirty="0" smtClean="0">
                 <a:solidFill>
                   <a:srgbClr val="000000"/>
                 </a:solidFill>
@@ -11106,18 +11106,7 @@
                 <a:ea typeface="微软雅黑" panose="020B0503020204020204" pitchFamily="34" charset="-122"/>
                 <a:sym typeface="+mn-ea"/>
               </a:rPr>
-              <a:t>背景</a:t>
-            </a:r>
-            <a:r>
-              <a:rPr sz="1200" dirty="0">
-                <a:solidFill>
-                  <a:srgbClr val="000000"/>
-                </a:solidFill>
-                <a:latin typeface="微软雅黑" panose="020B0503020204020204" pitchFamily="34" charset="-122"/>
-                <a:ea typeface="微软雅黑" panose="020B0503020204020204" pitchFamily="34" charset="-122"/>
-                <a:sym typeface="+mn-ea"/>
-              </a:rPr>
-              <a:t>：</a:t>
+              <a:t>背景：</a:t>
             </a:r>
             <a:r>
               <a:rPr lang="en-US" sz="1200" dirty="0">
@@ -11162,7 +11151,7 @@
               <a:defRPr/>
             </a:pPr>
             <a:r>
-              <a:rPr lang="zh-CN" sz="1200" dirty="0">
+              <a:rPr lang="zh-CN" altLang="en-US" sz="1200" b="1" dirty="0" smtClean="0">
                 <a:solidFill>
                   <a:srgbClr val="000000"/>
                 </a:solidFill>
@@ -11170,18 +11159,7 @@
                 <a:ea typeface="微软雅黑" panose="020B0503020204020204" pitchFamily="34" charset="-122"/>
                 <a:sym typeface="+mn-ea"/>
               </a:rPr>
-              <a:t>现状</a:t>
-            </a:r>
-            <a:r>
-              <a:rPr sz="1200" dirty="0">
-                <a:solidFill>
-                  <a:srgbClr val="000000"/>
-                </a:solidFill>
-                <a:latin typeface="微软雅黑" panose="020B0503020204020204" pitchFamily="34" charset="-122"/>
-                <a:ea typeface="微软雅黑" panose="020B0503020204020204" pitchFamily="34" charset="-122"/>
-                <a:sym typeface="+mn-ea"/>
-              </a:rPr>
-              <a:t>：</a:t>
+              <a:t>现状：</a:t>
             </a:r>
             <a:r>
               <a:rPr lang="en-US" sz="1200" dirty="0">
@@ -11229,7 +11207,7 @@
               <a:defRPr/>
             </a:pPr>
             <a:r>
-              <a:rPr lang="zh-CN" altLang="en-US" sz="1200" dirty="0" smtClean="0">
+              <a:rPr lang="zh-CN" altLang="en-US" sz="1200" b="1" dirty="0" smtClean="0">
                 <a:solidFill>
                   <a:srgbClr val="000000"/>
                 </a:solidFill>
@@ -11240,7 +11218,7 @@
               <a:t>系统策略</a:t>
             </a:r>
             <a:r>
-              <a:rPr lang="zh-CN" altLang="en-US" sz="1200" dirty="0" smtClean="0">
+              <a:rPr lang="zh-CN" altLang="en-US" sz="1200" b="1" dirty="0" smtClean="0">
                 <a:latin typeface="微软雅黑" panose="020B0503020204020204" pitchFamily="34" charset="-122"/>
                 <a:ea typeface="微软雅黑" panose="020B0503020204020204" pitchFamily="34" charset="-122"/>
                 <a:sym typeface="+mn-ea"/>
@@ -11279,7 +11257,7 @@
               <a:defRPr/>
             </a:pPr>
             <a:r>
-              <a:rPr lang="zh-CN" sz="1200" dirty="0" err="1" smtClean="0">
+              <a:rPr lang="zh-CN" sz="1200" b="1" dirty="0" err="1" smtClean="0">
                 <a:solidFill>
                   <a:srgbClr val="000000"/>
                 </a:solidFill>
@@ -11290,7 +11268,7 @@
               <a:t>策略逻辑</a:t>
             </a:r>
             <a:r>
-              <a:rPr lang="zh-CN" sz="1200" dirty="0" smtClean="0">
+              <a:rPr lang="zh-CN" sz="1200" b="1" dirty="0" smtClean="0">
                 <a:solidFill>
                   <a:srgbClr val="000000"/>
                 </a:solidFill>

</xml_diff>